<commit_message>
Simplify all decks for absolute beginners
Every theory concept now carries a plain-words companion right next to
the formal term, built on three coherent metaphor families (the exam:
leakage, cross-validation, ERM, selection vs assessment; the kitchen:
hyperparameters, pipelines, basis expansion; trees voting) plus source
devices (Ng's untunable radio, Harvard's poked holes) and a shoe-shop
device for structural vs estimation error. Jargon is inline-glossed at
first use; bullets carry one idea each.

Added speaker notes to 42 theory and metrics slides: a 2-4 sentence
talk track per slide with the metaphor spelled out and a question to
ask the class.

No changes to slide counts, order, figures (one jargon label glossed),
numbers, or attributions.

Co-Authored-By: Claude Fable 5 <noreply@anthropic.com>
</commit_message>
<xml_diff>
--- a/presentations/m2-session-1-machine-learning-fundamentals.pptx
+++ b/presentations/m2-session-1-machine-learning-fundamentals.pptx
@@ -8,23 +8,23 @@
     <p:sldId id="256" r:id="rId7"/>
     <p:sldId id="257" r:id="rId8"/>
     <p:sldId id="258" r:id="rId9"/>
-    <p:sldId id="259" r:id="rId10"/>
-    <p:sldId id="260" r:id="rId11"/>
-    <p:sldId id="261" r:id="rId12"/>
-    <p:sldId id="262" r:id="rId13"/>
-    <p:sldId id="263" r:id="rId14"/>
-    <p:sldId id="264" r:id="rId15"/>
-    <p:sldId id="265" r:id="rId16"/>
-    <p:sldId id="266" r:id="rId17"/>
-    <p:sldId id="267" r:id="rId18"/>
-    <p:sldId id="268" r:id="rId19"/>
-    <p:sldId id="269" r:id="rId20"/>
-    <p:sldId id="270" r:id="rId21"/>
-    <p:sldId id="271" r:id="rId22"/>
-    <p:sldId id="272" r:id="rId23"/>
-    <p:sldId id="273" r:id="rId24"/>
-    <p:sldId id="274" r:id="rId25"/>
-    <p:sldId id="275" r:id="rId26"/>
+    <p:sldId id="259" r:id="rId11"/>
+    <p:sldId id="260" r:id="rId12"/>
+    <p:sldId id="261" r:id="rId13"/>
+    <p:sldId id="262" r:id="rId14"/>
+    <p:sldId id="263" r:id="rId15"/>
+    <p:sldId id="264" r:id="rId16"/>
+    <p:sldId id="265" r:id="rId17"/>
+    <p:sldId id="266" r:id="rId18"/>
+    <p:sldId id="267" r:id="rId19"/>
+    <p:sldId id="268" r:id="rId20"/>
+    <p:sldId id="269" r:id="rId21"/>
+    <p:sldId id="270" r:id="rId22"/>
+    <p:sldId id="271" r:id="rId23"/>
+    <p:sldId id="272" r:id="rId24"/>
+    <p:sldId id="273" r:id="rId25"/>
+    <p:sldId id="274" r:id="rId26"/>
+    <p:sldId id="275" r:id="rId27"/>
   </p:sldIdLst>
   <p:sldSz cx="12191695" cy="6858000" type="screen4x3"/>
   <p:notesSz cx="6858000" cy="9144000"/>
@@ -124,6 +124,1196 @@
     </a:lvl9pPr>
   </p:defaultTextStyle>
 </p:presentation>
+</file>
+
+<file path=ppt/notesMasters/notesMaster1.xml><?xml version="1.0" encoding="utf-8"?>
+<p:notesMaster xmlns:a="http://schemas.openxmlformats.org/drawingml/2006/main" xmlns:p="http://schemas.openxmlformats.org/presentationml/2006/main" xmlns:r="http://schemas.openxmlformats.org/officeDocument/2006/relationships">
+  <p:cSld>
+    <p:bg>
+      <p:bgRef idx="1001">
+        <a:schemeClr val="bg1"/>
+      </p:bgRef>
+    </p:bg>
+    <p:spTree>
+      <p:nvGrpSpPr>
+        <p:cNvPr id="1" name=""/>
+        <p:cNvGrpSpPr/>
+        <p:nvPr/>
+      </p:nvGrpSpPr>
+      <p:grpSpPr>
+        <a:xfrm>
+          <a:off x="0" y="0"/>
+          <a:ext cx="0" cy="0"/>
+          <a:chOff x="0" y="0"/>
+          <a:chExt cx="0" cy="0"/>
+        </a:xfrm>
+      </p:grpSpPr>
+      <p:sp>
+        <p:nvSpPr>
+          <p:cNvPr id="2" name="Header Placeholder 1"/>
+          <p:cNvSpPr>
+            <a:spLocks noGrp="1"/>
+          </p:cNvSpPr>
+          <p:nvPr>
+            <p:ph type="hdr" sz="quarter"/>
+          </p:nvPr>
+        </p:nvSpPr>
+        <p:spPr>
+          <a:xfrm>
+            <a:off x="0" y="0"/>
+            <a:ext cx="2971800" cy="457200"/>
+          </a:xfrm>
+          <a:prstGeom prst="rect">
+            <a:avLst/>
+          </a:prstGeom>
+        </p:spPr>
+        <p:txBody>
+          <a:bodyPr vert="horz" lIns="91440" tIns="45720" rIns="91440" bIns="45720" rtlCol="0"/>
+          <a:lstStyle>
+            <a:lvl1pPr algn="l">
+              <a:defRPr sz="1200"/>
+            </a:lvl1pPr>
+          </a:lstStyle>
+          <a:p>
+            <a:endParaRPr lang="en-US"/>
+          </a:p>
+        </p:txBody>
+      </p:sp>
+      <p:sp>
+        <p:nvSpPr>
+          <p:cNvPr id="3" name="Date Placeholder 2"/>
+          <p:cNvSpPr>
+            <a:spLocks noGrp="1"/>
+          </p:cNvSpPr>
+          <p:nvPr>
+            <p:ph type="dt" idx="1"/>
+          </p:nvPr>
+        </p:nvSpPr>
+        <p:spPr>
+          <a:xfrm>
+            <a:off x="3884613" y="0"/>
+            <a:ext cx="2971800" cy="457200"/>
+          </a:xfrm>
+          <a:prstGeom prst="rect">
+            <a:avLst/>
+          </a:prstGeom>
+        </p:spPr>
+        <p:txBody>
+          <a:bodyPr vert="horz" lIns="91440" tIns="45720" rIns="91440" bIns="45720" rtlCol="0"/>
+          <a:lstStyle>
+            <a:lvl1pPr algn="r">
+              <a:defRPr sz="1200"/>
+            </a:lvl1pPr>
+          </a:lstStyle>
+          <a:p>
+            <a:fld id="{0F89C1C7-3DCD-1040-A9CF-14679D8B5DDD}" type="datetimeFigureOut">
+              <a:rPr lang="en-US" smtClean="0"/>
+              <a:t>10/17/16</a:t>
+            </a:fld>
+            <a:endParaRPr lang="en-US"/>
+          </a:p>
+        </p:txBody>
+      </p:sp>
+      <p:sp>
+        <p:nvSpPr>
+          <p:cNvPr id="4" name="Slide Image Placeholder 3"/>
+          <p:cNvSpPr>
+            <a:spLocks noGrp="1" noRot="1" noChangeAspect="1"/>
+          </p:cNvSpPr>
+          <p:nvPr>
+            <p:ph type="sldImg" idx="2"/>
+          </p:nvPr>
+        </p:nvSpPr>
+        <p:spPr>
+          <a:xfrm>
+            <a:off x="1143000" y="685800"/>
+            <a:ext cx="4572000" cy="3429000"/>
+          </a:xfrm>
+          <a:prstGeom prst="rect">
+            <a:avLst/>
+          </a:prstGeom>
+          <a:noFill/>
+          <a:ln w="12700">
+            <a:solidFill>
+              <a:prstClr val="black"/>
+            </a:solidFill>
+          </a:ln>
+        </p:spPr>
+        <p:txBody>
+          <a:bodyPr vert="horz" lIns="91440" tIns="45720" rIns="91440" bIns="45720" rtlCol="0" anchor="ctr"/>
+          <a:lstStyle/>
+          <a:p>
+            <a:endParaRPr lang="en-US"/>
+          </a:p>
+        </p:txBody>
+      </p:sp>
+      <p:sp>
+        <p:nvSpPr>
+          <p:cNvPr id="5" name="Notes Placeholder 4"/>
+          <p:cNvSpPr>
+            <a:spLocks noGrp="1"/>
+          </p:cNvSpPr>
+          <p:nvPr>
+            <p:ph type="body" sz="quarter" idx="3"/>
+          </p:nvPr>
+        </p:nvSpPr>
+        <p:spPr>
+          <a:xfrm>
+            <a:off x="685800" y="4343400"/>
+            <a:ext cx="5486400" cy="4114800"/>
+          </a:xfrm>
+          <a:prstGeom prst="rect">
+            <a:avLst/>
+          </a:prstGeom>
+        </p:spPr>
+        <p:txBody>
+          <a:bodyPr vert="horz" lIns="91440" tIns="45720" rIns="91440" bIns="45720" rtlCol="0"/>
+          <a:lstStyle/>
+          <a:p>
+            <a:pPr lvl="0"/>
+            <a:r>
+              <a:rPr lang="en-US" smtClean="0"/>
+              <a:t>Click to edit Master text styles</a:t>
+            </a:r>
+          </a:p>
+          <a:p>
+            <a:pPr lvl="1"/>
+            <a:r>
+              <a:rPr lang="en-US" smtClean="0"/>
+              <a:t>Second level</a:t>
+            </a:r>
+          </a:p>
+          <a:p>
+            <a:pPr lvl="2"/>
+            <a:r>
+              <a:rPr lang="en-US" smtClean="0"/>
+              <a:t>Third level</a:t>
+            </a:r>
+          </a:p>
+          <a:p>
+            <a:pPr lvl="3"/>
+            <a:r>
+              <a:rPr lang="en-US" smtClean="0"/>
+              <a:t>Fourth level</a:t>
+            </a:r>
+          </a:p>
+          <a:p>
+            <a:pPr lvl="4"/>
+            <a:r>
+              <a:rPr lang="en-US" smtClean="0"/>
+              <a:t>Fifth level</a:t>
+            </a:r>
+            <a:endParaRPr lang="en-US"/>
+          </a:p>
+        </p:txBody>
+      </p:sp>
+      <p:sp>
+        <p:nvSpPr>
+          <p:cNvPr id="6" name="Footer Placeholder 5"/>
+          <p:cNvSpPr>
+            <a:spLocks noGrp="1"/>
+          </p:cNvSpPr>
+          <p:nvPr>
+            <p:ph type="ftr" sz="quarter" idx="4"/>
+          </p:nvPr>
+        </p:nvSpPr>
+        <p:spPr>
+          <a:xfrm>
+            <a:off x="0" y="8685213"/>
+            <a:ext cx="2971800" cy="457200"/>
+          </a:xfrm>
+          <a:prstGeom prst="rect">
+            <a:avLst/>
+          </a:prstGeom>
+        </p:spPr>
+        <p:txBody>
+          <a:bodyPr vert="horz" lIns="91440" tIns="45720" rIns="91440" bIns="45720" rtlCol="0" anchor="b"/>
+          <a:lstStyle>
+            <a:lvl1pPr algn="l">
+              <a:defRPr sz="1200"/>
+            </a:lvl1pPr>
+          </a:lstStyle>
+          <a:p>
+            <a:endParaRPr lang="en-US"/>
+          </a:p>
+        </p:txBody>
+      </p:sp>
+      <p:sp>
+        <p:nvSpPr>
+          <p:cNvPr id="7" name="Slide Number Placeholder 6"/>
+          <p:cNvSpPr>
+            <a:spLocks noGrp="1"/>
+          </p:cNvSpPr>
+          <p:nvPr>
+            <p:ph type="sldNum" sz="quarter" idx="5"/>
+          </p:nvPr>
+        </p:nvSpPr>
+        <p:spPr>
+          <a:xfrm>
+            <a:off x="3884613" y="8685213"/>
+            <a:ext cx="2971800" cy="457200"/>
+          </a:xfrm>
+          <a:prstGeom prst="rect">
+            <a:avLst/>
+          </a:prstGeom>
+        </p:spPr>
+        <p:txBody>
+          <a:bodyPr vert="horz" lIns="91440" tIns="45720" rIns="91440" bIns="45720" rtlCol="0" anchor="b"/>
+          <a:lstStyle>
+            <a:lvl1pPr algn="r">
+              <a:defRPr sz="1200"/>
+            </a:lvl1pPr>
+          </a:lstStyle>
+          <a:p>
+            <a:fld id="{BB5E49A5-4136-284D-997B-48E1D791AD67}" type="slidenum">
+              <a:rPr lang="en-US" smtClean="0"/>
+              <a:t>‹#›</a:t>
+            </a:fld>
+            <a:endParaRPr lang="en-US"/>
+          </a:p>
+        </p:txBody>
+      </p:sp>
+    </p:spTree>
+    <p:extLst>
+      <p:ext uri="{BB962C8B-B14F-4D97-AF65-F5344CB8AC3E}">
+        <p14:creationId xmlns:p14="http://schemas.microsoft.com/office/powerpoint/2010/main" val="2623252185"/>
+      </p:ext>
+    </p:extLst>
+  </p:cSld>
+  <p:clrMap bg1="lt1" tx1="dk1" bg2="lt2" tx2="dk2" accent1="accent1" accent2="accent2" accent3="accent3" accent4="accent4" accent5="accent5" accent6="accent6" hlink="hlink" folHlink="folHlink"/>
+  <p:notesStyle>
+    <a:lvl1pPr marL="0" algn="l" defTabSz="457200" rtl="0" eaLnBrk="1" latinLnBrk="0" hangingPunct="1">
+      <a:defRPr sz="1200" kern="1200">
+        <a:solidFill>
+          <a:schemeClr val="tx1"/>
+        </a:solidFill>
+        <a:latin typeface="+mn-lt"/>
+        <a:ea typeface="+mn-ea"/>
+        <a:cs typeface="+mn-cs"/>
+      </a:defRPr>
+    </a:lvl1pPr>
+    <a:lvl2pPr marL="457200" algn="l" defTabSz="457200" rtl="0" eaLnBrk="1" latinLnBrk="0" hangingPunct="1">
+      <a:defRPr sz="1200" kern="1200">
+        <a:solidFill>
+          <a:schemeClr val="tx1"/>
+        </a:solidFill>
+        <a:latin typeface="+mn-lt"/>
+        <a:ea typeface="+mn-ea"/>
+        <a:cs typeface="+mn-cs"/>
+      </a:defRPr>
+    </a:lvl2pPr>
+    <a:lvl3pPr marL="914400" algn="l" defTabSz="457200" rtl="0" eaLnBrk="1" latinLnBrk="0" hangingPunct="1">
+      <a:defRPr sz="1200" kern="1200">
+        <a:solidFill>
+          <a:schemeClr val="tx1"/>
+        </a:solidFill>
+        <a:latin typeface="+mn-lt"/>
+        <a:ea typeface="+mn-ea"/>
+        <a:cs typeface="+mn-cs"/>
+      </a:defRPr>
+    </a:lvl3pPr>
+    <a:lvl4pPr marL="1371600" algn="l" defTabSz="457200" rtl="0" eaLnBrk="1" latinLnBrk="0" hangingPunct="1">
+      <a:defRPr sz="1200" kern="1200">
+        <a:solidFill>
+          <a:schemeClr val="tx1"/>
+        </a:solidFill>
+        <a:latin typeface="+mn-lt"/>
+        <a:ea typeface="+mn-ea"/>
+        <a:cs typeface="+mn-cs"/>
+      </a:defRPr>
+    </a:lvl4pPr>
+    <a:lvl5pPr marL="1828800" algn="l" defTabSz="457200" rtl="0" eaLnBrk="1" latinLnBrk="0" hangingPunct="1">
+      <a:defRPr sz="1200" kern="1200">
+        <a:solidFill>
+          <a:schemeClr val="tx1"/>
+        </a:solidFill>
+        <a:latin typeface="+mn-lt"/>
+        <a:ea typeface="+mn-ea"/>
+        <a:cs typeface="+mn-cs"/>
+      </a:defRPr>
+    </a:lvl5pPr>
+    <a:lvl6pPr marL="2286000" algn="l" defTabSz="457200" rtl="0" eaLnBrk="1" latinLnBrk="0" hangingPunct="1">
+      <a:defRPr sz="1200" kern="1200">
+        <a:solidFill>
+          <a:schemeClr val="tx1"/>
+        </a:solidFill>
+        <a:latin typeface="+mn-lt"/>
+        <a:ea typeface="+mn-ea"/>
+        <a:cs typeface="+mn-cs"/>
+      </a:defRPr>
+    </a:lvl6pPr>
+    <a:lvl7pPr marL="2743200" algn="l" defTabSz="457200" rtl="0" eaLnBrk="1" latinLnBrk="0" hangingPunct="1">
+      <a:defRPr sz="1200" kern="1200">
+        <a:solidFill>
+          <a:schemeClr val="tx1"/>
+        </a:solidFill>
+        <a:latin typeface="+mn-lt"/>
+        <a:ea typeface="+mn-ea"/>
+        <a:cs typeface="+mn-cs"/>
+      </a:defRPr>
+    </a:lvl7pPr>
+    <a:lvl8pPr marL="3200400" algn="l" defTabSz="457200" rtl="0" eaLnBrk="1" latinLnBrk="0" hangingPunct="1">
+      <a:defRPr sz="1200" kern="1200">
+        <a:solidFill>
+          <a:schemeClr val="tx1"/>
+        </a:solidFill>
+        <a:latin typeface="+mn-lt"/>
+        <a:ea typeface="+mn-ea"/>
+        <a:cs typeface="+mn-cs"/>
+      </a:defRPr>
+    </a:lvl8pPr>
+    <a:lvl9pPr marL="3657600" algn="l" defTabSz="457200" rtl="0" eaLnBrk="1" latinLnBrk="0" hangingPunct="1">
+      <a:defRPr sz="1200" kern="1200">
+        <a:solidFill>
+          <a:schemeClr val="tx1"/>
+        </a:solidFill>
+        <a:latin typeface="+mn-lt"/>
+        <a:ea typeface="+mn-ea"/>
+        <a:cs typeface="+mn-cs"/>
+      </a:defRPr>
+    </a:lvl9pPr>
+  </p:notesStyle>
+</p:notesMaster>
+</file>
+
+<file path=ppt/notesSlides/notesSlide1.xml><?xml version="1.0" encoding="utf-8"?>
+<p:notes xmlns:a="http://schemas.openxmlformats.org/drawingml/2006/main" xmlns:p="http://schemas.openxmlformats.org/presentationml/2006/main" xmlns:r="http://schemas.openxmlformats.org/officeDocument/2006/relationships">
+  <p:cSld>
+    <p:spTree>
+      <p:nvGrpSpPr>
+        <p:cNvPr id="1" name=""/>
+        <p:cNvGrpSpPr/>
+        <p:nvPr/>
+      </p:nvGrpSpPr>
+      <p:grpSpPr>
+        <a:xfrm>
+          <a:off x="0" y="0"/>
+          <a:ext cx="0" cy="0"/>
+          <a:chOff x="0" y="0"/>
+          <a:chExt cx="0" cy="0"/>
+        </a:xfrm>
+      </p:grpSpPr>
+      <p:sp>
+        <p:nvSpPr>
+          <p:cNvPr id="2" name="Slide Image Placeholder 1"/>
+          <p:cNvSpPr>
+            <a:spLocks noGrp="1"/>
+          </p:cNvSpPr>
+          <p:nvPr>
+            <p:ph type="sldImg" idx="2"/>
+          </p:nvPr>
+        </p:nvSpPr>
+        <p:spPr/>
+      </p:sp>
+      <p:sp>
+        <p:nvSpPr>
+          <p:cNvPr id="3" name="Notes Placeholder 2"/>
+          <p:cNvSpPr>
+            <a:spLocks noGrp="1"/>
+          </p:cNvSpPr>
+          <p:nvPr>
+            <p:ph type="body" idx="3" sz="quarter"/>
+          </p:nvPr>
+        </p:nvSpPr>
+        <p:spPr/>
+        <p:txBody>
+          <a:bodyPr/>
+          <a:lstStyle/>
+          <a:p>
+            <a:r>
+              <a:t>Start from what they already know: in M1 they answered 'what happened' with charts a person reads. Machine learning answers a new question - 'what will happen to a NEW case' - and the answer is something a program can act on. Same data, different question. Ask the class: the app that predicts when your bus arrives - which of the two rows is it on?</a:t>
+            </a:r>
+          </a:p>
+        </p:txBody>
+      </p:sp>
+      <p:sp>
+        <p:nvSpPr>
+          <p:cNvPr id="4" name="Slide Number Placeholder 3"/>
+          <p:cNvSpPr>
+            <a:spLocks noGrp="1"/>
+          </p:cNvSpPr>
+          <p:nvPr>
+            <p:ph type="sldNum" idx="5" sz="quarter"/>
+          </p:nvPr>
+        </p:nvSpPr>
+        <p:spPr/>
+      </p:sp>
+    </p:spTree>
+  </p:cSld>
+  <p:clrMapOvr>
+    <a:masterClrMapping/>
+  </p:clrMapOvr>
+</p:notes>
+</file>
+
+<file path=ppt/notesSlides/notesSlide10.xml><?xml version="1.0" encoding="utf-8"?>
+<p:notes xmlns:a="http://schemas.openxmlformats.org/drawingml/2006/main" xmlns:p="http://schemas.openxmlformats.org/presentationml/2006/main" xmlns:r="http://schemas.openxmlformats.org/officeDocument/2006/relationships">
+  <p:cSld>
+    <p:spTree>
+      <p:nvGrpSpPr>
+        <p:cNvPr id="1" name=""/>
+        <p:cNvGrpSpPr/>
+        <p:nvPr/>
+      </p:nvGrpSpPr>
+      <p:grpSpPr>
+        <a:xfrm>
+          <a:off x="0" y="0"/>
+          <a:ext cx="0" cy="0"/>
+          <a:chOff x="0" y="0"/>
+          <a:chExt cx="0" cy="0"/>
+        </a:xfrm>
+      </p:grpSpPr>
+      <p:sp>
+        <p:nvSpPr>
+          <p:cNvPr id="2" name="Slide Image Placeholder 1"/>
+          <p:cNvSpPr>
+            <a:spLocks noGrp="1"/>
+          </p:cNvSpPr>
+          <p:nvPr>
+            <p:ph type="sldImg" idx="2"/>
+          </p:nvPr>
+        </p:nvSpPr>
+        <p:spPr/>
+      </p:sp>
+      <p:sp>
+        <p:nvSpPr>
+          <p:cNvPr id="3" name="Notes Placeholder 2"/>
+          <p:cNvSpPr>
+            <a:spLocks noGrp="1"/>
+          </p:cNvSpPr>
+          <p:nvPr>
+            <p:ph type="body" idx="3" sz="quarter"/>
+          </p:nvPr>
+        </p:nvSpPr>
+        <p:spPr/>
+        <p:txBody>
+          <a:bodyPr/>
+          <a:lstStyle/>
+          <a:p>
+            <a:r>
+              <a:t>Demystify training: score every candidate rule by its average miss - one number, J - and hunt for the rule with the smallest J. The hunt is a walk downhill in fog: feel the slope, step where it drops fastest, repeat. Point at the four panels: bad rule big J, decent rule smaller, best rule smallest. Ask the class: what goes wrong if your downhill steps are huge?</a:t>
+            </a:r>
+          </a:p>
+        </p:txBody>
+      </p:sp>
+      <p:sp>
+        <p:nvSpPr>
+          <p:cNvPr id="4" name="Slide Number Placeholder 3"/>
+          <p:cNvSpPr>
+            <a:spLocks noGrp="1"/>
+          </p:cNvSpPr>
+          <p:nvPr>
+            <p:ph type="sldNum" idx="5" sz="quarter"/>
+          </p:nvPr>
+        </p:nvSpPr>
+        <p:spPr/>
+      </p:sp>
+    </p:spTree>
+  </p:cSld>
+  <p:clrMapOvr>
+    <a:masterClrMapping/>
+  </p:clrMapOvr>
+</p:notes>
+</file>
+
+<file path=ppt/notesSlides/notesSlide11.xml><?xml version="1.0" encoding="utf-8"?>
+<p:notes xmlns:a="http://schemas.openxmlformats.org/drawingml/2006/main" xmlns:p="http://schemas.openxmlformats.org/presentationml/2006/main" xmlns:r="http://schemas.openxmlformats.org/officeDocument/2006/relationships">
+  <p:cSld>
+    <p:spTree>
+      <p:nvGrpSpPr>
+        <p:cNvPr id="1" name=""/>
+        <p:cNvGrpSpPr/>
+        <p:nvPr/>
+      </p:nvGrpSpPr>
+      <p:grpSpPr>
+        <a:xfrm>
+          <a:off x="0" y="0"/>
+          <a:ext cx="0" cy="0"/>
+          <a:chOff x="0" y="0"/>
+          <a:chExt cx="0" cy="0"/>
+        </a:xfrm>
+      </p:grpSpPr>
+      <p:sp>
+        <p:nvSpPr>
+          <p:cNvPr id="2" name="Slide Image Placeholder 1"/>
+          <p:cNvSpPr>
+            <a:spLocks noGrp="1"/>
+          </p:cNvSpPr>
+          <p:nvPr>
+            <p:ph type="sldImg" idx="2"/>
+          </p:nvPr>
+        </p:nvSpPr>
+        <p:spPr/>
+      </p:sp>
+      <p:sp>
+        <p:nvSpPr>
+          <p:cNvPr id="3" name="Notes Placeholder 2"/>
+          <p:cNvSpPr>
+            <a:spLocks noGrp="1"/>
+          </p:cNvSpPr>
+          <p:nvPr>
+            <p:ph type="body" idx="3" sz="quarter"/>
+          </p:nvPr>
+        </p:nvSpPr>
+        <p:spPr/>
+        <p:txBody>
+          <a:bodyPr/>
+          <a:lstStyle/>
+          <a:p>
+            <a:r>
+              <a:t>This is the module's exam metaphor - use it every session: the test set is the final exam, and you sit it exactly once. Leakage is any way the exam answers sneak into the study notes - even an average computed over all rows counts. Tell the KDD story slowly: the patient ID gave away the hospital, and the hospital gave away the diagnosis. Ask the class: why does a suspiciously good feature deserve suspicion first?</a:t>
+            </a:r>
+          </a:p>
+        </p:txBody>
+      </p:sp>
+      <p:sp>
+        <p:nvSpPr>
+          <p:cNvPr id="4" name="Slide Number Placeholder 3"/>
+          <p:cNvSpPr>
+            <a:spLocks noGrp="1"/>
+          </p:cNvSpPr>
+          <p:nvPr>
+            <p:ph type="sldNum" idx="5" sz="quarter"/>
+          </p:nvPr>
+        </p:nvSpPr>
+        <p:spPr/>
+      </p:sp>
+    </p:spTree>
+  </p:cSld>
+  <p:clrMapOvr>
+    <a:masterClrMapping/>
+  </p:clrMapOvr>
+</p:notes>
+</file>
+
+<file path=ppt/notesSlides/notesSlide12.xml><?xml version="1.0" encoding="utf-8"?>
+<p:notes xmlns:a="http://schemas.openxmlformats.org/drawingml/2006/main" xmlns:p="http://schemas.openxmlformats.org/presentationml/2006/main" xmlns:r="http://schemas.openxmlformats.org/officeDocument/2006/relationships">
+  <p:cSld>
+    <p:spTree>
+      <p:nvGrpSpPr>
+        <p:cNvPr id="1" name=""/>
+        <p:cNvGrpSpPr/>
+        <p:nvPr/>
+      </p:nvGrpSpPr>
+      <p:grpSpPr>
+        <a:xfrm>
+          <a:off x="0" y="0"/>
+          <a:ext cx="0" cy="0"/>
+          <a:chOff x="0" y="0"/>
+          <a:chExt cx="0" cy="0"/>
+        </a:xfrm>
+      </p:grpSpPr>
+      <p:sp>
+        <p:nvSpPr>
+          <p:cNvPr id="2" name="Slide Image Placeholder 1"/>
+          <p:cNvSpPr>
+            <a:spLocks noGrp="1"/>
+          </p:cNvSpPr>
+          <p:nvPr>
+            <p:ph type="sldImg" idx="2"/>
+          </p:nvPr>
+        </p:nvSpPr>
+        <p:spPr/>
+      </p:sp>
+      <p:sp>
+        <p:nvSpPr>
+          <p:cNvPr id="3" name="Notes Placeholder 2"/>
+          <p:cNvSpPr>
+            <a:spLocks noGrp="1"/>
+          </p:cNvSpPr>
+          <p:nvPr>
+            <p:ph type="body" idx="3" sz="quarter"/>
+          </p:nvPr>
+        </p:nvSpPr>
+        <p:spPr/>
+        <p:txBody>
+          <a:bodyPr/>
+          <a:lstStyle/>
+          <a:p>
+            <a:r>
+              <a:t>A model that ignores everything and always answers 'died' is right 61.7% of the time, simply because most passengers died. That is the floor: any real model must clearly beat it, or it has learned nothing. Ask the class: why is 62% accuracy on this dataset nothing to celebrate?</a:t>
+            </a:r>
+          </a:p>
+        </p:txBody>
+      </p:sp>
+      <p:sp>
+        <p:nvSpPr>
+          <p:cNvPr id="4" name="Slide Number Placeholder 3"/>
+          <p:cNvSpPr>
+            <a:spLocks noGrp="1"/>
+          </p:cNvSpPr>
+          <p:nvPr>
+            <p:ph type="sldNum" idx="5" sz="quarter"/>
+          </p:nvPr>
+        </p:nvSpPr>
+        <p:spPr/>
+      </p:sp>
+    </p:spTree>
+  </p:cSld>
+  <p:clrMapOvr>
+    <a:masterClrMapping/>
+  </p:clrMapOvr>
+</p:notes>
+</file>
+
+<file path=ppt/notesSlides/notesSlide2.xml><?xml version="1.0" encoding="utf-8"?>
+<p:notes xmlns:a="http://schemas.openxmlformats.org/drawingml/2006/main" xmlns:p="http://schemas.openxmlformats.org/presentationml/2006/main" xmlns:r="http://schemas.openxmlformats.org/officeDocument/2006/relationships">
+  <p:cSld>
+    <p:spTree>
+      <p:nvGrpSpPr>
+        <p:cNvPr id="1" name=""/>
+        <p:cNvGrpSpPr/>
+        <p:nvPr/>
+      </p:nvGrpSpPr>
+      <p:grpSpPr>
+        <a:xfrm>
+          <a:off x="0" y="0"/>
+          <a:ext cx="0" cy="0"/>
+          <a:chOff x="0" y="0"/>
+          <a:chExt cx="0" cy="0"/>
+        </a:xfrm>
+      </p:grpSpPr>
+      <p:sp>
+        <p:nvSpPr>
+          <p:cNvPr id="2" name="Slide Image Placeholder 1"/>
+          <p:cNvSpPr>
+            <a:spLocks noGrp="1"/>
+          </p:cNvSpPr>
+          <p:nvPr>
+            <p:ph type="sldImg" idx="2"/>
+          </p:nvPr>
+        </p:nvSpPr>
+        <p:spPr/>
+      </p:sp>
+      <p:sp>
+        <p:nvSpPr>
+          <p:cNvPr id="3" name="Notes Placeholder 2"/>
+          <p:cNvSpPr>
+            <a:spLocks noGrp="1"/>
+          </p:cNvSpPr>
+          <p:nvPr>
+            <p:ph type="body" idx="3" sz="quarter"/>
+          </p:nvPr>
+        </p:nvSpPr>
+        <p:spPr/>
+        <p:txBody>
+          <a:bodyPr/>
+          <a:lstStyle/>
+          <a:p>
+            <a:r>
+              <a:t>Reassure them: this module is one rung up, not a new ladder. They already climbed the first two rungs in M1, and those skills stay in daily use. Point at each rung and say its question out loud - what happened, why, what will happen, what should we do. Ask the class: where on this ladder does a weather forecast sit?</a:t>
+            </a:r>
+          </a:p>
+        </p:txBody>
+      </p:sp>
+      <p:sp>
+        <p:nvSpPr>
+          <p:cNvPr id="4" name="Slide Number Placeholder 3"/>
+          <p:cNvSpPr>
+            <a:spLocks noGrp="1"/>
+          </p:cNvSpPr>
+          <p:nvPr>
+            <p:ph type="sldNum" idx="5" sz="quarter"/>
+          </p:nvPr>
+        </p:nvSpPr>
+        <p:spPr/>
+      </p:sp>
+    </p:spTree>
+  </p:cSld>
+  <p:clrMapOvr>
+    <a:masterClrMapping/>
+  </p:clrMapOvr>
+</p:notes>
+</file>
+
+<file path=ppt/notesSlides/notesSlide3.xml><?xml version="1.0" encoding="utf-8"?>
+<p:notes xmlns:a="http://schemas.openxmlformats.org/drawingml/2006/main" xmlns:p="http://schemas.openxmlformats.org/presentationml/2006/main" xmlns:r="http://schemas.openxmlformats.org/officeDocument/2006/relationships">
+  <p:cSld>
+    <p:spTree>
+      <p:nvGrpSpPr>
+        <p:cNvPr id="1" name=""/>
+        <p:cNvGrpSpPr/>
+        <p:nvPr/>
+      </p:nvGrpSpPr>
+      <p:grpSpPr>
+        <a:xfrm>
+          <a:off x="0" y="0"/>
+          <a:ext cx="0" cy="0"/>
+          <a:chOff x="0" y="0"/>
+          <a:chExt cx="0" cy="0"/>
+        </a:xfrm>
+      </p:grpSpPr>
+      <p:sp>
+        <p:nvSpPr>
+          <p:cNvPr id="2" name="Slide Image Placeholder 1"/>
+          <p:cNvSpPr>
+            <a:spLocks noGrp="1"/>
+          </p:cNvSpPr>
+          <p:nvPr>
+            <p:ph type="sldImg" idx="2"/>
+          </p:nvPr>
+        </p:nvSpPr>
+        <p:spPr/>
+      </p:sp>
+      <p:sp>
+        <p:nvSpPr>
+          <p:cNvPr id="3" name="Notes Placeholder 2"/>
+          <p:cNvSpPr>
+            <a:spLocks noGrp="1"/>
+          </p:cNvSpPr>
+          <p:nvPr>
+            <p:ph type="body" idx="3" sz="quarter"/>
+          </p:nvPr>
+        </p:nvSpPr>
+        <p:spPr/>
+        <p:txBody>
+          <a:bodyPr/>
+          <a:lstStyle/>
+          <a:p>
+            <a:r>
+              <a:t>Two ways to get rules into a computer: write them yourself, or show labeled examples and let the algorithm find the rules. Spam is the perfect story - a hand-written rule list never ends, spammers adapt faster than you type. Ask the class: what would YOUR three spam rules be, and how would a spammer dodge each one within a week?</a:t>
+            </a:r>
+          </a:p>
+        </p:txBody>
+      </p:sp>
+      <p:sp>
+        <p:nvSpPr>
+          <p:cNvPr id="4" name="Slide Number Placeholder 3"/>
+          <p:cNvSpPr>
+            <a:spLocks noGrp="1"/>
+          </p:cNvSpPr>
+          <p:nvPr>
+            <p:ph type="sldNum" idx="5" sz="quarter"/>
+          </p:nvPr>
+        </p:nvSpPr>
+        <p:spPr/>
+      </p:sp>
+    </p:spTree>
+  </p:cSld>
+  <p:clrMapOvr>
+    <a:masterClrMapping/>
+  </p:clrMapOvr>
+</p:notes>
+</file>
+
+<file path=ppt/notesSlides/notesSlide4.xml><?xml version="1.0" encoding="utf-8"?>
+<p:notes xmlns:a="http://schemas.openxmlformats.org/drawingml/2006/main" xmlns:p="http://schemas.openxmlformats.org/presentationml/2006/main" xmlns:r="http://schemas.openxmlformats.org/officeDocument/2006/relationships">
+  <p:cSld>
+    <p:spTree>
+      <p:nvGrpSpPr>
+        <p:cNvPr id="1" name=""/>
+        <p:cNvGrpSpPr/>
+        <p:nvPr/>
+      </p:nvGrpSpPr>
+      <p:grpSpPr>
+        <a:xfrm>
+          <a:off x="0" y="0"/>
+          <a:ext cx="0" cy="0"/>
+          <a:chOff x="0" y="0"/>
+          <a:chExt cx="0" cy="0"/>
+        </a:xfrm>
+      </p:grpSpPr>
+      <p:sp>
+        <p:nvSpPr>
+          <p:cNvPr id="2" name="Slide Image Placeholder 1"/>
+          <p:cNvSpPr>
+            <a:spLocks noGrp="1"/>
+          </p:cNvSpPr>
+          <p:nvPr>
+            <p:ph type="sldImg" idx="2"/>
+          </p:nvPr>
+        </p:nvSpPr>
+        <p:spPr/>
+      </p:sp>
+      <p:sp>
+        <p:nvSpPr>
+          <p:cNvPr id="3" name="Notes Placeholder 2"/>
+          <p:cNvSpPr>
+            <a:spLocks noGrp="1"/>
+          </p:cNvSpPr>
+          <p:nvPr>
+            <p:ph type="body" idx="3" sz="quarter"/>
+          </p:nvPr>
+        </p:nvSpPr>
+        <p:spPr/>
+        <p:txBody>
+          <a:bodyPr/>
+          <a:lstStyle/>
+          <a:p>
+            <a:r>
+              <a:t>The three families differ only in what the data hands you: the right answers (supervised), no answers (unsupervised), or only consequences after acting (reinforcement). Everything in this module is supervised - our passengers come with the answer attached: survived or not. Ask the class: grouping customers into types nobody named in advance - which family is that?</a:t>
+            </a:r>
+          </a:p>
+        </p:txBody>
+      </p:sp>
+      <p:sp>
+        <p:nvSpPr>
+          <p:cNvPr id="4" name="Slide Number Placeholder 3"/>
+          <p:cNvSpPr>
+            <a:spLocks noGrp="1"/>
+          </p:cNvSpPr>
+          <p:nvPr>
+            <p:ph type="sldNum" idx="5" sz="quarter"/>
+          </p:nvPr>
+        </p:nvSpPr>
+        <p:spPr/>
+      </p:sp>
+    </p:spTree>
+  </p:cSld>
+  <p:clrMapOvr>
+    <a:masterClrMapping/>
+  </p:clrMapOvr>
+</p:notes>
+</file>
+
+<file path=ppt/notesSlides/notesSlide5.xml><?xml version="1.0" encoding="utf-8"?>
+<p:notes xmlns:a="http://schemas.openxmlformats.org/drawingml/2006/main" xmlns:p="http://schemas.openxmlformats.org/presentationml/2006/main" xmlns:r="http://schemas.openxmlformats.org/officeDocument/2006/relationships">
+  <p:cSld>
+    <p:spTree>
+      <p:nvGrpSpPr>
+        <p:cNvPr id="1" name=""/>
+        <p:cNvGrpSpPr/>
+        <p:nvPr/>
+      </p:nvGrpSpPr>
+      <p:grpSpPr>
+        <a:xfrm>
+          <a:off x="0" y="0"/>
+          <a:ext cx="0" cy="0"/>
+          <a:chOff x="0" y="0"/>
+          <a:chExt cx="0" cy="0"/>
+        </a:xfrm>
+      </p:grpSpPr>
+      <p:sp>
+        <p:nvSpPr>
+          <p:cNvPr id="2" name="Slide Image Placeholder 1"/>
+          <p:cNvSpPr>
+            <a:spLocks noGrp="1"/>
+          </p:cNvSpPr>
+          <p:nvPr>
+            <p:ph type="sldImg" idx="2"/>
+          </p:nvPr>
+        </p:nvSpPr>
+        <p:spPr/>
+      </p:sp>
+      <p:sp>
+        <p:nvSpPr>
+          <p:cNvPr id="3" name="Notes Placeholder 2"/>
+          <p:cNvSpPr>
+            <a:spLocks noGrp="1"/>
+          </p:cNvSpPr>
+          <p:nvPr>
+            <p:ph type="body" idx="3" sz="quarter"/>
+          </p:nvPr>
+        </p:nvSpPr>
+        <p:spPr/>
+        <p:txBody>
+          <a:bodyPr/>
+          <a:lstStyle/>
+          <a:p>
+            <a:r>
+              <a:t>Keep it physical: X is every column that describes a passenger, y is the one column we want to predict. Category out means classification, number out means regression - that is the whole distinction. Ask the class: same table, but now predict the Fare a passenger paid - classification or regression?</a:t>
+            </a:r>
+          </a:p>
+        </p:txBody>
+      </p:sp>
+      <p:sp>
+        <p:nvSpPr>
+          <p:cNvPr id="4" name="Slide Number Placeholder 3"/>
+          <p:cNvSpPr>
+            <a:spLocks noGrp="1"/>
+          </p:cNvSpPr>
+          <p:nvPr>
+            <p:ph type="sldNum" idx="5" sz="quarter"/>
+          </p:nvPr>
+        </p:nvSpPr>
+        <p:spPr/>
+      </p:sp>
+    </p:spTree>
+  </p:cSld>
+  <p:clrMapOvr>
+    <a:masterClrMapping/>
+  </p:clrMapOvr>
+</p:notes>
+</file>
+
+<file path=ppt/notesSlides/notesSlide6.xml><?xml version="1.0" encoding="utf-8"?>
+<p:notes xmlns:a="http://schemas.openxmlformats.org/drawingml/2006/main" xmlns:p="http://schemas.openxmlformats.org/presentationml/2006/main" xmlns:r="http://schemas.openxmlformats.org/officeDocument/2006/relationships">
+  <p:cSld>
+    <p:spTree>
+      <p:nvGrpSpPr>
+        <p:cNvPr id="1" name=""/>
+        <p:cNvGrpSpPr/>
+        <p:nvPr/>
+      </p:nvGrpSpPr>
+      <p:grpSpPr>
+        <a:xfrm>
+          <a:off x="0" y="0"/>
+          <a:ext cx="0" cy="0"/>
+          <a:chOff x="0" y="0"/>
+          <a:chExt cx="0" cy="0"/>
+        </a:xfrm>
+      </p:grpSpPr>
+      <p:sp>
+        <p:nvSpPr>
+          <p:cNvPr id="2" name="Slide Image Placeholder 1"/>
+          <p:cNvSpPr>
+            <a:spLocks noGrp="1"/>
+          </p:cNvSpPr>
+          <p:nvPr>
+            <p:ph type="sldImg" idx="2"/>
+          </p:nvPr>
+        </p:nvSpPr>
+        <p:spPr/>
+      </p:sp>
+      <p:sp>
+        <p:nvSpPr>
+          <p:cNvPr id="3" name="Notes Placeholder 2"/>
+          <p:cNvSpPr>
+            <a:spLocks noGrp="1"/>
+          </p:cNvSpPr>
+          <p:nvPr>
+            <p:ph type="body" idx="3" sz="quarter"/>
+          </p:nvPr>
+        </p:nvSpPr>
+        <p:spPr/>
+        <p:txBody>
+          <a:bodyPr/>
+          <a:lstStyle/>
+          <a:p>
+            <a:r>
+              <a:t>Say it as: every outcome is pattern plus luck. The pattern is learnable - class, sex and age really did shape survival. The luck is not: two identical passengers could meet different fates in the chaos. Better features and models shrink the pattern error; nothing shrinks the luck. Ask the class: why would a model claiming 100% accuracy on survival actually be suspicious?</a:t>
+            </a:r>
+          </a:p>
+        </p:txBody>
+      </p:sp>
+      <p:sp>
+        <p:nvSpPr>
+          <p:cNvPr id="4" name="Slide Number Placeholder 3"/>
+          <p:cNvSpPr>
+            <a:spLocks noGrp="1"/>
+          </p:cNvSpPr>
+          <p:nvPr>
+            <p:ph type="sldNum" idx="5" sz="quarter"/>
+          </p:nvPr>
+        </p:nvSpPr>
+        <p:spPr/>
+      </p:sp>
+    </p:spTree>
+  </p:cSld>
+  <p:clrMapOvr>
+    <a:masterClrMapping/>
+  </p:clrMapOvr>
+</p:notes>
+</file>
+
+<file path=ppt/notesSlides/notesSlide7.xml><?xml version="1.0" encoding="utf-8"?>
+<p:notes xmlns:a="http://schemas.openxmlformats.org/drawingml/2006/main" xmlns:p="http://schemas.openxmlformats.org/presentationml/2006/main" xmlns:r="http://schemas.openxmlformats.org/officeDocument/2006/relationships">
+  <p:cSld>
+    <p:spTree>
+      <p:nvGrpSpPr>
+        <p:cNvPr id="1" name=""/>
+        <p:cNvGrpSpPr/>
+        <p:nvPr/>
+      </p:nvGrpSpPr>
+      <p:grpSpPr>
+        <a:xfrm>
+          <a:off x="0" y="0"/>
+          <a:ext cx="0" cy="0"/>
+          <a:chOff x="0" y="0"/>
+          <a:chExt cx="0" cy="0"/>
+        </a:xfrm>
+      </p:grpSpPr>
+      <p:sp>
+        <p:nvSpPr>
+          <p:cNvPr id="2" name="Slide Image Placeholder 1"/>
+          <p:cNvSpPr>
+            <a:spLocks noGrp="1"/>
+          </p:cNvSpPr>
+          <p:nvPr>
+            <p:ph type="sldImg" idx="2"/>
+          </p:nvPr>
+        </p:nvSpPr>
+        <p:spPr/>
+      </p:sp>
+      <p:sp>
+        <p:nvSpPr>
+          <p:cNvPr id="3" name="Notes Placeholder 2"/>
+          <p:cNvSpPr>
+            <a:spLocks noGrp="1"/>
+          </p:cNvSpPr>
+          <p:nvPr>
+            <p:ph type="body" idx="3" sz="quarter"/>
+          </p:nvPr>
+        </p:nvSpPr>
+        <p:spPr/>
+        <p:txBody>
+          <a:bodyPr/>
+          <a:lstStyle/>
+          <a:p>
+            <a:r>
+              <a:t>Lead with the dog photos: after ten photos of dogs you recognize an eleventh you have never seen - that is all learning is. It works only because tomorrow resembles yesterday; that assumption is the bridge, not a proof. Ask the class: give me a case where tomorrow does NOT resemble yesterday - would a model trained on the past still work?</a:t>
+            </a:r>
+          </a:p>
+        </p:txBody>
+      </p:sp>
+      <p:sp>
+        <p:nvSpPr>
+          <p:cNvPr id="4" name="Slide Number Placeholder 3"/>
+          <p:cNvSpPr>
+            <a:spLocks noGrp="1"/>
+          </p:cNvSpPr>
+          <p:nvPr>
+            <p:ph type="sldNum" idx="5" sz="quarter"/>
+          </p:nvPr>
+        </p:nvSpPr>
+        <p:spPr/>
+      </p:sp>
+    </p:spTree>
+  </p:cSld>
+  <p:clrMapOvr>
+    <a:masterClrMapping/>
+  </p:clrMapOvr>
+</p:notes>
+</file>
+
+<file path=ppt/notesSlides/notesSlide8.xml><?xml version="1.0" encoding="utf-8"?>
+<p:notes xmlns:a="http://schemas.openxmlformats.org/drawingml/2006/main" xmlns:p="http://schemas.openxmlformats.org/presentationml/2006/main" xmlns:r="http://schemas.openxmlformats.org/officeDocument/2006/relationships">
+  <p:cSld>
+    <p:spTree>
+      <p:nvGrpSpPr>
+        <p:cNvPr id="1" name=""/>
+        <p:cNvGrpSpPr/>
+        <p:nvPr/>
+      </p:nvGrpSpPr>
+      <p:grpSpPr>
+        <a:xfrm>
+          <a:off x="0" y="0"/>
+          <a:ext cx="0" cy="0"/>
+          <a:chOff x="0" y="0"/>
+          <a:chExt cx="0" cy="0"/>
+        </a:xfrm>
+      </p:grpSpPr>
+      <p:sp>
+        <p:nvSpPr>
+          <p:cNvPr id="2" name="Slide Image Placeholder 1"/>
+          <p:cNvSpPr>
+            <a:spLocks noGrp="1"/>
+          </p:cNvSpPr>
+          <p:nvPr>
+            <p:ph type="sldImg" idx="2"/>
+          </p:nvPr>
+        </p:nvSpPr>
+        <p:spPr/>
+      </p:sp>
+      <p:sp>
+        <p:nvSpPr>
+          <p:cNvPr id="3" name="Notes Placeholder 2"/>
+          <p:cNvSpPr>
+            <a:spLocks noGrp="1"/>
+          </p:cNvSpPr>
+          <p:nvPr>
+            <p:ph type="body" idx="3" sz="quarter"/>
+          </p:nvPr>
+        </p:nvSpPr>
+        <p:spPr/>
+        <p:txBody>
+          <a:bodyPr/>
+          <a:lstStyle/>
+          <a:p>
+            <a:r>
+              <a:t>The one-liner: you decide the shape of the answer - a line or a curve - and training only finds the best rule of that shape. Point at the faint lines: those are the candidates the family allows; the bold one is what the search returns. Ask the class: if the true pattern is a curve and you only allow straight lines, can training ever fix that?</a:t>
+            </a:r>
+          </a:p>
+        </p:txBody>
+      </p:sp>
+      <p:sp>
+        <p:nvSpPr>
+          <p:cNvPr id="4" name="Slide Number Placeholder 3"/>
+          <p:cNvSpPr>
+            <a:spLocks noGrp="1"/>
+          </p:cNvSpPr>
+          <p:nvPr>
+            <p:ph type="sldNum" idx="5" sz="quarter"/>
+          </p:nvPr>
+        </p:nvSpPr>
+        <p:spPr/>
+      </p:sp>
+    </p:spTree>
+  </p:cSld>
+  <p:clrMapOvr>
+    <a:masterClrMapping/>
+  </p:clrMapOvr>
+</p:notes>
+</file>
+
+<file path=ppt/notesSlides/notesSlide9.xml><?xml version="1.0" encoding="utf-8"?>
+<p:notes xmlns:a="http://schemas.openxmlformats.org/drawingml/2006/main" xmlns:p="http://schemas.openxmlformats.org/presentationml/2006/main" xmlns:r="http://schemas.openxmlformats.org/officeDocument/2006/relationships">
+  <p:cSld>
+    <p:spTree>
+      <p:nvGrpSpPr>
+        <p:cNvPr id="1" name=""/>
+        <p:cNvGrpSpPr/>
+        <p:nvPr/>
+      </p:nvGrpSpPr>
+      <p:grpSpPr>
+        <a:xfrm>
+          <a:off x="0" y="0"/>
+          <a:ext cx="0" cy="0"/>
+          <a:chOff x="0" y="0"/>
+          <a:chExt cx="0" cy="0"/>
+        </a:xfrm>
+      </p:grpSpPr>
+      <p:sp>
+        <p:nvSpPr>
+          <p:cNvPr id="2" name="Slide Image Placeholder 1"/>
+          <p:cNvSpPr>
+            <a:spLocks noGrp="1"/>
+          </p:cNvSpPr>
+          <p:nvPr>
+            <p:ph type="sldImg" idx="2"/>
+          </p:nvPr>
+        </p:nvSpPr>
+        <p:spPr/>
+      </p:sp>
+      <p:sp>
+        <p:nvSpPr>
+          <p:cNvPr id="3" name="Notes Placeholder 2"/>
+          <p:cNvSpPr>
+            <a:spLocks noGrp="1"/>
+          </p:cNvSpPr>
+          <p:nvPr>
+            <p:ph type="body" idx="3" sz="quarter"/>
+          </p:nvPr>
+        </p:nvSpPr>
+        <p:spPr/>
+        <p:txBody>
+          <a:bodyPr/>
+          <a:lstStyle/>
+          <a:p>
+            <a:r>
+              <a:t>This is the most reusable slide of the module: every learner they will ever meet is a menu of candidate rules, a scorecard for wrongness, and a search for the best-scoring rule. Walk the worked filling underneath: logistic regression is just one way to fill the three slots. Ask the class: which slot did the previous slide - the hypothesis class - cover?</a:t>
+            </a:r>
+          </a:p>
+        </p:txBody>
+      </p:sp>
+      <p:sp>
+        <p:nvSpPr>
+          <p:cNvPr id="4" name="Slide Number Placeholder 3"/>
+          <p:cNvSpPr>
+            <a:spLocks noGrp="1"/>
+          </p:cNvSpPr>
+          <p:nvPr>
+            <p:ph type="sldNum" idx="5" sz="quarter"/>
+          </p:nvPr>
+        </p:nvSpPr>
+        <p:spPr/>
+      </p:sp>
+    </p:spTree>
+  </p:cSld>
+  <p:clrMapOvr>
+    <a:masterClrMapping/>
+  </p:clrMapOvr>
+</p:notes>
 </file>
 
 <file path=ppt/slideLayouts/slideLayout1.xml><?xml version="1.0" encoding="utf-8"?>
@@ -3623,7 +4813,7 @@
                 </a:solidFill>
                 <a:latin typeface="Arial"/>
               </a:rPr>
-              <a:t>A hypothesis is one concrete rule with its numbers filled in; the hypothesis class is the whole family of rules of that shape</a:t>
+              <a:t>Hypothesis class - in plain words: you pick the shape of the answer (a line? a curve?)</a:t>
             </a:r>
           </a:p>
           <a:p>
@@ -3643,7 +4833,7 @@
                 </a:solidFill>
                 <a:latin typeface="Arial"/>
               </a:rPr>
-              <a:t>Learning is a SEARCH: the algorithm scans the family and returns the member that fits the examples best</a:t>
+              <a:t>One hypothesis = one concrete rule, numbers filled in; the class = all rules of that shape</a:t>
             </a:r>
           </a:p>
           <a:p>
@@ -3663,7 +4853,7 @@
                 </a:solidFill>
                 <a:latin typeface="Arial"/>
               </a:rPr>
-              <a:t>Which family to search is YOUR design decision, made before any data is touched: straight lines, or flexible curves?</a:t>
+              <a:t>Learning is a search: the algorithm scans the family and returns the member that fits best</a:t>
             </a:r>
           </a:p>
           <a:p>
@@ -3683,7 +4873,7 @@
                 </a:solidFill>
                 <a:latin typeface="Arial"/>
               </a:rPr>
-              <a:t>Flexibility cuts both ways: a roomier family can follow the pattern more closely - and can follow the noise too</a:t>
+              <a:t>You pick the family before touching any data - that design call is yours, not the algorithm's</a:t>
             </a:r>
           </a:p>
           <a:p>
@@ -3703,7 +4893,27 @@
                 </a:solidFill>
                 <a:latin typeface="Arial"/>
               </a:rPr>
-              <a:t>MIT separates model selection (choose the class) from model fitting (find the member) - Session 3 turns exactly this dial</a:t>
+              <a:t>A roomier family follows the pattern more closely - and follows the noise too; it cuts both ways</a:t>
+            </a:r>
+          </a:p>
+          <a:p>
+            <a:pPr algn="l" indent="-228600" marL="228600">
+              <a:spcAft>
+                <a:spcPts val="800"/>
+              </a:spcAft>
+              <a:buClr>
+                <a:srgbClr val="1E5EF3"/>
+              </a:buClr>
+              <a:buChar char="—"/>
+            </a:pPr>
+            <a:r>
+              <a:rPr sz="1450" b="0">
+                <a:solidFill>
+                  <a:srgbClr val="202B38"/>
+                </a:solidFill>
+                <a:latin typeface="Arial"/>
+              </a:rPr>
+              <a:t>MIT splits it: choose the class (Session 3's dial) vs fit the member (training's job)</a:t>
             </a:r>
           </a:p>
         </p:txBody>
@@ -4120,7 +5330,7 @@
                 </a:solidFill>
                 <a:latin typeface="Arial"/>
               </a:rPr>
-              <a:t>Every supervised learner is the same three-slot recipe: a set of candidate rules (the model), a score for how wrong a prediction is (the loss), and a search that finds the best-scoring rule (the optimizer).</a:t>
+              <a:t>The three-slot recipe - in plain words: a menu of rules + a scorecard + a search</a:t>
             </a:r>
           </a:p>
           <a:p>
@@ -4140,7 +5350,7 @@
                 </a:solidFill>
                 <a:latin typeface="Arial"/>
               </a:rPr>
-              <a:t>Slot 1 is the hypothesis class you just met - choosing it stays YOUR call, made before any data is touched</a:t>
+              <a:t>Slot 1, the model: the hypothesis class you just met - your call, made before any data</a:t>
             </a:r>
           </a:p>
           <a:p>
@@ -4160,7 +5370,7 @@
                 </a:solidFill>
                 <a:latin typeface="Arial"/>
               </a:rPr>
-              <a:t>Different ML methods = different fillings of the same three slots</a:t>
+              <a:t>Slot 2, the loss: how bad is each wrong answer? Simplest scorecard: just count mistakes</a:t>
             </a:r>
           </a:p>
           <a:p>
@@ -4180,7 +5390,27 @@
                 </a:solidFill>
                 <a:latin typeface="Arial"/>
               </a:rPr>
-              <a:t>Session 3 refills slot 1 six times; Session 4 tunes the knobs around the recipe</a:t>
+              <a:t>Slot 3, the optimizer: the search that finds the family member with the best score</a:t>
+            </a:r>
+          </a:p>
+          <a:p>
+            <a:pPr algn="l" indent="-228600" marL="228600">
+              <a:spcAft>
+                <a:spcPts val="800"/>
+              </a:spcAft>
+              <a:buClr>
+                <a:srgbClr val="1E5EF3"/>
+              </a:buClr>
+              <a:buChar char="—"/>
+            </a:pPr>
+            <a:r>
+              <a:rPr sz="1450" b="0">
+                <a:solidFill>
+                  <a:srgbClr val="202B38"/>
+                </a:solidFill>
+                <a:latin typeface="Arial"/>
+              </a:rPr>
+              <a:t>Every ML method = a different filling of the same slots; Session 3 refills slot 1 six times</a:t>
             </a:r>
           </a:p>
         </p:txBody>
@@ -4597,7 +5827,7 @@
                 </a:solidFill>
                 <a:latin typeface="Arial"/>
               </a:rPr>
-              <a:t>Every candidate rule makes errors on the 891 labeled examples; average them into one number J - the cost</a:t>
+              <a:t>The cost J - in plain words: the average miss over all 891 examples - one number per rule</a:t>
             </a:r>
           </a:p>
           <a:p>
@@ -4617,7 +5847,7 @@
                 </a:solidFill>
                 <a:latin typeface="Arial"/>
               </a:rPr>
-              <a:t>J scores how badly a rule fits ALL the data at once - training = searching for the rule with the smallest J</a:t>
+              <a:t>Training = the search for the rule with the smallest J - nothing more mystical than that</a:t>
             </a:r>
           </a:p>
           <a:p>
@@ -4637,7 +5867,7 @@
                 </a:solidFill>
                 <a:latin typeface="Arial"/>
               </a:rPr>
-              <a:t>The search walks downhill: from any starting guess, nudge the knobs in the direction that lowers J fastest - a hillside descent in fog</a:t>
+              <a:t>The search walks downhill in fog: nudge the knobs in whichever direction lowers J fastest</a:t>
             </a:r>
           </a:p>
           <a:p>
@@ -5376,7 +6606,7 @@
                 </a:solidFill>
                 <a:latin typeface="Arial"/>
               </a:rPr>
-              <a:t>549 died, 342 survived: imbalanced, but not extremely</a:t>
+              <a:t>549 died, 342 survived: imbalanced (far from 50/50), but not extremely</a:t>
             </a:r>
           </a:p>
           <a:p>
@@ -8608,7 +9838,7 @@
                 </a:solidFill>
                 <a:latin typeface="Arial"/>
               </a:rPr>
-              <a:t>Data leakage = test-set information sneaking into training - even 'fill missing ages with the average' leaks if that average used all rows</a:t>
+              <a:t>The test set is the final exam - you sit it once; seeing the questions while studying proves nothing</a:t>
             </a:r>
           </a:p>
           <a:p>
@@ -8628,7 +9858,7 @@
                 </a:solidFill>
                 <a:latin typeface="Arial"/>
               </a:rPr>
-              <a:t>Analogy: the test set is the final exam - seeing the questions while studying inflates your score and proves nothing</a:t>
+              <a:t>Data leakage - in plain words: exam answers sneaking into your study notes</a:t>
             </a:r>
           </a:p>
           <a:p>
@@ -8648,7 +9878,7 @@
                 </a:solidFill>
                 <a:latin typeface="Arial"/>
               </a:rPr>
-              <a:t>stratify=y keeps the survivor share equal in both halves</a:t>
+              <a:t>Even 'fill missing ages with the average' leaks, if that average was computed over all rows</a:t>
             </a:r>
           </a:p>
           <a:p>
@@ -8668,7 +9898,27 @@
                 </a:solidFill>
                 <a:latin typeface="Arial"/>
               </a:rPr>
-              <a:t>Leakage bites professionals: KDD Cup 2008 teams found 'Patient ID' predicted breast cancer - the ID encoded which hospital, not the tumor</a:t>
+              <a:t>stratify=y - in plain words: keep the survivor share equal in both halves</a:t>
+            </a:r>
+          </a:p>
+          <a:p>
+            <a:pPr algn="l" indent="-228600" marL="228600">
+              <a:spcAft>
+                <a:spcPts val="800"/>
+              </a:spcAft>
+              <a:buClr>
+                <a:srgbClr val="1E5EF3"/>
+              </a:buClr>
+              <a:buChar char="—"/>
+            </a:pPr>
+            <a:r>
+              <a:rPr sz="1450" b="0">
+                <a:solidFill>
+                  <a:srgbClr val="202B38"/>
+                </a:solidFill>
+                <a:latin typeface="Arial"/>
+              </a:rPr>
+              <a:t>Leakage bites pros: KDD Cup 2008 - 'Patient ID' predicted cancer because the ID encoded the hospital, not the tumor</a:t>
             </a:r>
           </a:p>
           <a:p>
@@ -9669,7 +10919,7 @@
                 </a:solidFill>
                 <a:latin typeface="Arial"/>
               </a:rPr>
-              <a:t>Part 1, the ideas: ML learns rules from labeled examples - a leap from seen cases to unseen ones, licensed by one assumption (new data looks like old)</a:t>
+              <a:t>Part 1, the ideas: ML learns rules from labeled examples - a leap from seen cases to unseen ones, allowed by one assumption (new data looks like old)</a:t>
             </a:r>
           </a:p>
           <a:p>
@@ -10596,7 +11846,7 @@
                 </a:solidFill>
                 <a:latin typeface="Arial"/>
               </a:rPr>
-              <a:t>Your M1 skills stay load-bearing: 80% of the daily job is still cleaning and describing data</a:t>
+              <a:t>Your M1 skills still do most of the daily job: 80% of the work is still cleaning and describing data</a:t>
             </a:r>
           </a:p>
           <a:p>
@@ -12243,7 +13493,7 @@
                 </a:solidFill>
                 <a:latin typeface="Arial"/>
               </a:rPr>
-              <a:t>Also called predictors or covariates - the whole table is n observations x p predictors</a:t>
+              <a:t>Books also say predictors or covariates - different words, same idea: the input columns</a:t>
             </a:r>
           </a:p>
         </p:txBody>
@@ -12823,7 +14073,7 @@
                 </a:solidFill>
                 <a:latin typeface="Arial"/>
               </a:rPr>
-              <a:t>The outcome is a hidden rule plus noise: Y = f(X) + ε. Learning estimates the rule; nothing can predict the noise. Error you can shrink is reducible; the noise floor is irreducible.</a:t>
+              <a:t>Y = f(X) + ε - in plain words: every outcome is pattern plus luck</a:t>
             </a:r>
           </a:p>
           <a:p>
@@ -12843,7 +14093,7 @@
                 </a:solidFill>
                 <a:latin typeface="Arial"/>
               </a:rPr>
-              <a:t>On the Titanic: survival = some true, unknown rule of class, sex, age... plus randomness no manifest records</a:t>
+              <a:t>f is the pattern - learnable. ε (epsilon) is the luck - nothing predicts a coin flip</a:t>
             </a:r>
           </a:p>
           <a:p>
@@ -12863,7 +14113,7 @@
                 </a:solidFill>
                 <a:latin typeface="Arial"/>
               </a:rPr>
-              <a:t>A model is an estimate f-hat of the hidden rule - learning = estimating f from noisy samples</a:t>
+              <a:t>On the Titanic: class, sex and age shape survival (the pattern); chaos that night is the luck</a:t>
             </a:r>
           </a:p>
           <a:p>
@@ -12883,7 +14133,7 @@
                 </a:solidFill>
                 <a:latin typeface="Arial"/>
               </a:rPr>
-              <a:t>Better features, models, or data shrink reducible error; ε - chaos on a sinking ship - yields to no model, however perfect</a:t>
+              <a:t>A model estimates the pattern; the error you can still shrink is called reducible</a:t>
             </a:r>
           </a:p>
           <a:p>
@@ -12903,7 +14153,7 @@
                 </a:solidFill>
                 <a:latin typeface="Arial"/>
               </a:rPr>
-              <a:t>This is why 100% accuracy is not the goal and never will be - Session 3 pays this off</a:t>
+              <a:t>The luck is an irreducible floor - why 100% accuracy is never the goal; Session 3 pays this off</a:t>
             </a:r>
           </a:p>
         </p:txBody>
@@ -13320,7 +14570,7 @@
                 </a:solidFill>
                 <a:latin typeface="Arial"/>
               </a:rPr>
-              <a:t>Every learner makes the same leap: finitely many examples in, a rule that must answer for cases nobody has seen yet</a:t>
+              <a:t>The induction problem - in plain words: after 10 dog photos you recognize an 11th you never saw</a:t>
             </a:r>
           </a:p>
           <a:p>
@@ -13340,7 +14590,7 @@
                 </a:solidFill>
                 <a:latin typeface="Arial"/>
               </a:rPr>
-              <a:t>Philosophers call it the problem of induction: nothing logically guarantees the future resembles the past</a:t>
+              <a:t>Every learner makes that leap: a few examples in, answers for cases nobody has seen yet</a:t>
             </a:r>
           </a:p>
           <a:p>
@@ -13360,7 +14610,7 @@
                 </a:solidFill>
                 <a:latin typeface="Arial"/>
               </a:rPr>
-              <a:t>MIT splits the difficulty in two: estimation - see through the noise in the data you have - and generalization - say something about inputs you never saw</a:t>
+              <a:t>Nothing guarantees the future resembles the past - the leap rests on one assumption</a:t>
             </a:r>
           </a:p>
           <a:p>
@@ -13380,7 +14630,7 @@
                 </a:solidFill>
                 <a:latin typeface="Arial"/>
               </a:rPr>
-              <a:t>The bridge is an assumption, not a proof: new data is drawn from the same world as the old (i.i.d.) - no assumption, no generalization</a:t>
+              <a:t>The assumption (called i.i.d.): new data looks like old - no assumption, no leap</a:t>
             </a:r>
           </a:p>
           <a:p>
@@ -13400,7 +14650,27 @@
                 </a:solidFill>
                 <a:latin typeface="Arial"/>
               </a:rPr>
-              <a:t>Part 2 builds exactly this leap: 712 passengers teach a rule that 179 unseen ones will judge</a:t>
+              <a:t>MIT splits the job in two: estimation - see through the noise; generalization - answer for inputs never seen</a:t>
+            </a:r>
+          </a:p>
+          <a:p>
+            <a:pPr algn="l" indent="-228600" marL="228600">
+              <a:spcAft>
+                <a:spcPts val="800"/>
+              </a:spcAft>
+              <a:buClr>
+                <a:srgbClr val="1E5EF3"/>
+              </a:buClr>
+              <a:buChar char="—"/>
+            </a:pPr>
+            <a:r>
+              <a:rPr sz="1450" b="0">
+                <a:solidFill>
+                  <a:srgbClr val="202B38"/>
+                </a:solidFill>
+                <a:latin typeface="Arial"/>
+              </a:rPr>
+              <a:t>Part 2 builds this exact leap: 712 passengers teach a rule; 179 unseen ones judge it</a:t>
             </a:r>
           </a:p>
         </p:txBody>
@@ -13875,4 +15145,324 @@
   </a:objectDefaults>
   <a:extraClrSchemeLst/>
 </a:theme>
+</file>
+
+<file path=ppt/theme/theme2.xml><?xml version="1.0" encoding="utf-8"?>
+<a:theme xmlns:a="http://schemas.openxmlformats.org/drawingml/2006/main" name="Office Theme">
+  <a:themeElements>
+    <a:clrScheme name="Office">
+      <a:dk1>
+        <a:sysClr val="windowText" lastClr="000000"/>
+      </a:dk1>
+      <a:lt1>
+        <a:sysClr val="window" lastClr="FFFFFF"/>
+      </a:lt1>
+      <a:dk2>
+        <a:srgbClr val="1F497D"/>
+      </a:dk2>
+      <a:lt2>
+        <a:srgbClr val="EEECE1"/>
+      </a:lt2>
+      <a:accent1>
+        <a:srgbClr val="4F81BD"/>
+      </a:accent1>
+      <a:accent2>
+        <a:srgbClr val="C0504D"/>
+      </a:accent2>
+      <a:accent3>
+        <a:srgbClr val="9BBB59"/>
+      </a:accent3>
+      <a:accent4>
+        <a:srgbClr val="8064A2"/>
+      </a:accent4>
+      <a:accent5>
+        <a:srgbClr val="4BACC6"/>
+      </a:accent5>
+      <a:accent6>
+        <a:srgbClr val="F79646"/>
+      </a:accent6>
+      <a:hlink>
+        <a:srgbClr val="0000FF"/>
+      </a:hlink>
+      <a:folHlink>
+        <a:srgbClr val="800080"/>
+      </a:folHlink>
+    </a:clrScheme>
+    <a:fontScheme name="Office">
+      <a:majorFont>
+        <a:latin typeface="Calibri"/>
+        <a:ea typeface=""/>
+        <a:cs typeface=""/>
+        <a:font script="Jpan" typeface="ＭＳ Ｐゴシック"/>
+        <a:font script="Hang" typeface="맑은 고딕"/>
+        <a:font script="Hans" typeface="宋体"/>
+        <a:font script="Hant" typeface="新細明體"/>
+        <a:font script="Arab" typeface="Times New Roman"/>
+        <a:font script="Hebr" typeface="Times New Roman"/>
+        <a:font script="Thai" typeface="Angsana New"/>
+        <a:font script="Ethi" typeface="Nyala"/>
+        <a:font script="Beng" typeface="Vrinda"/>
+        <a:font script="Gujr" typeface="Shruti"/>
+        <a:font script="Khmr" typeface="MoolBoran"/>
+        <a:font script="Knda" typeface="Tunga"/>
+        <a:font script="Guru" typeface="Raavi"/>
+        <a:font script="Cans" typeface="Euphemia"/>
+        <a:font script="Cher" typeface="Plantagenet Cherokee"/>
+        <a:font script="Yiii" typeface="Microsoft Yi Baiti"/>
+        <a:font script="Tibt" typeface="Microsoft Himalaya"/>
+        <a:font script="Thaa" typeface="MV Boli"/>
+        <a:font script="Deva" typeface="Mangal"/>
+        <a:font script="Telu" typeface="Gautami"/>
+        <a:font script="Taml" typeface="Latha"/>
+        <a:font script="Syrc" typeface="Estrangelo Edessa"/>
+        <a:font script="Orya" typeface="Kalinga"/>
+        <a:font script="Mlym" typeface="Kartika"/>
+        <a:font script="Laoo" typeface="DokChampa"/>
+        <a:font script="Sinh" typeface="Iskoola Pota"/>
+        <a:font script="Mong" typeface="Mongolian Baiti"/>
+        <a:font script="Viet" typeface="Times New Roman"/>
+        <a:font script="Uigh" typeface="Microsoft Uighur"/>
+        <a:font script="Geor" typeface="Sylfaen"/>
+      </a:majorFont>
+      <a:minorFont>
+        <a:latin typeface="Calibri"/>
+        <a:ea typeface=""/>
+        <a:cs typeface=""/>
+        <a:font script="Jpan" typeface="ＭＳ Ｐゴシック"/>
+        <a:font script="Hang" typeface="맑은 고딕"/>
+        <a:font script="Hans" typeface="宋体"/>
+        <a:font script="Hant" typeface="新細明體"/>
+        <a:font script="Arab" typeface="Arial"/>
+        <a:font script="Hebr" typeface="Arial"/>
+        <a:font script="Thai" typeface="Cordia New"/>
+        <a:font script="Ethi" typeface="Nyala"/>
+        <a:font script="Beng" typeface="Vrinda"/>
+        <a:font script="Gujr" typeface="Shruti"/>
+        <a:font script="Khmr" typeface="DaunPenh"/>
+        <a:font script="Knda" typeface="Tunga"/>
+        <a:font script="Guru" typeface="Raavi"/>
+        <a:font script="Cans" typeface="Euphemia"/>
+        <a:font script="Cher" typeface="Plantagenet Cherokee"/>
+        <a:font script="Yiii" typeface="Microsoft Yi Baiti"/>
+        <a:font script="Tibt" typeface="Microsoft Himalaya"/>
+        <a:font script="Thaa" typeface="MV Boli"/>
+        <a:font script="Deva" typeface="Mangal"/>
+        <a:font script="Telu" typeface="Gautami"/>
+        <a:font script="Taml" typeface="Latha"/>
+        <a:font script="Syrc" typeface="Estrangelo Edessa"/>
+        <a:font script="Orya" typeface="Kalinga"/>
+        <a:font script="Mlym" typeface="Kartika"/>
+        <a:font script="Laoo" typeface="DokChampa"/>
+        <a:font script="Sinh" typeface="Iskoola Pota"/>
+        <a:font script="Mong" typeface="Mongolian Baiti"/>
+        <a:font script="Viet" typeface="Arial"/>
+        <a:font script="Uigh" typeface="Microsoft Uighur"/>
+        <a:font script="Geor" typeface="Sylfaen"/>
+      </a:minorFont>
+    </a:fontScheme>
+    <a:fmtScheme name="Office">
+      <a:fillStyleLst>
+        <a:solidFill>
+          <a:schemeClr val="phClr"/>
+        </a:solidFill>
+        <a:gradFill rotWithShape="1">
+          <a:gsLst>
+            <a:gs pos="0">
+              <a:schemeClr val="phClr">
+                <a:tint val="50000"/>
+                <a:satMod val="300000"/>
+              </a:schemeClr>
+            </a:gs>
+            <a:gs pos="35000">
+              <a:schemeClr val="phClr">
+                <a:tint val="37000"/>
+                <a:satMod val="300000"/>
+              </a:schemeClr>
+            </a:gs>
+            <a:gs pos="100000">
+              <a:schemeClr val="phClr">
+                <a:tint val="15000"/>
+                <a:satMod val="350000"/>
+              </a:schemeClr>
+            </a:gs>
+          </a:gsLst>
+          <a:lin ang="16200000" scaled="1"/>
+        </a:gradFill>
+        <a:gradFill rotWithShape="1">
+          <a:gsLst>
+            <a:gs pos="0">
+              <a:schemeClr val="phClr">
+                <a:tint val="100000"/>
+                <a:shade val="100000"/>
+                <a:satMod val="130000"/>
+              </a:schemeClr>
+            </a:gs>
+            <a:gs pos="100000">
+              <a:schemeClr val="phClr">
+                <a:tint val="50000"/>
+                <a:shade val="100000"/>
+                <a:satMod val="350000"/>
+              </a:schemeClr>
+            </a:gs>
+          </a:gsLst>
+          <a:lin ang="16200000" scaled="0"/>
+        </a:gradFill>
+      </a:fillStyleLst>
+      <a:lnStyleLst>
+        <a:ln w="9525" cap="flat" cmpd="sng" algn="ctr">
+          <a:solidFill>
+            <a:schemeClr val="phClr">
+              <a:shade val="95000"/>
+              <a:satMod val="105000"/>
+            </a:schemeClr>
+          </a:solidFill>
+          <a:prstDash val="solid"/>
+        </a:ln>
+        <a:ln w="25400" cap="flat" cmpd="sng" algn="ctr">
+          <a:solidFill>
+            <a:schemeClr val="phClr"/>
+          </a:solidFill>
+          <a:prstDash val="solid"/>
+        </a:ln>
+        <a:ln w="38100" cap="flat" cmpd="sng" algn="ctr">
+          <a:solidFill>
+            <a:schemeClr val="phClr"/>
+          </a:solidFill>
+          <a:prstDash val="solid"/>
+        </a:ln>
+      </a:lnStyleLst>
+      <a:effectStyleLst>
+        <a:effectStyle>
+          <a:effectLst>
+            <a:outerShdw blurRad="40000" dist="20000" dir="5400000" rotWithShape="0">
+              <a:srgbClr val="000000">
+                <a:alpha val="38000"/>
+              </a:srgbClr>
+            </a:outerShdw>
+          </a:effectLst>
+        </a:effectStyle>
+        <a:effectStyle>
+          <a:effectLst>
+            <a:outerShdw blurRad="40000" dist="23000" dir="5400000" rotWithShape="0">
+              <a:srgbClr val="000000">
+                <a:alpha val="35000"/>
+              </a:srgbClr>
+            </a:outerShdw>
+          </a:effectLst>
+        </a:effectStyle>
+        <a:effectStyle>
+          <a:effectLst>
+            <a:outerShdw blurRad="40000" dist="23000" dir="5400000" rotWithShape="0">
+              <a:srgbClr val="000000">
+                <a:alpha val="35000"/>
+              </a:srgbClr>
+            </a:outerShdw>
+          </a:effectLst>
+          <a:scene3d>
+            <a:camera prst="orthographicFront">
+              <a:rot lat="0" lon="0" rev="0"/>
+            </a:camera>
+            <a:lightRig rig="threePt" dir="t">
+              <a:rot lat="0" lon="0" rev="1200000"/>
+            </a:lightRig>
+          </a:scene3d>
+          <a:sp3d>
+            <a:bevelT w="63500" h="25400"/>
+          </a:sp3d>
+        </a:effectStyle>
+      </a:effectStyleLst>
+      <a:bgFillStyleLst>
+        <a:solidFill>
+          <a:schemeClr val="phClr"/>
+        </a:solidFill>
+        <a:gradFill rotWithShape="1">
+          <a:gsLst>
+            <a:gs pos="0">
+              <a:schemeClr val="phClr">
+                <a:tint val="40000"/>
+                <a:satMod val="350000"/>
+              </a:schemeClr>
+            </a:gs>
+            <a:gs pos="40000">
+              <a:schemeClr val="phClr">
+                <a:tint val="45000"/>
+                <a:shade val="99000"/>
+                <a:satMod val="350000"/>
+              </a:schemeClr>
+            </a:gs>
+            <a:gs pos="100000">
+              <a:schemeClr val="phClr">
+                <a:shade val="20000"/>
+                <a:satMod val="255000"/>
+              </a:schemeClr>
+            </a:gs>
+          </a:gsLst>
+          <a:path path="circle">
+            <a:fillToRect l="50000" t="-80000" r="50000" b="180000"/>
+          </a:path>
+        </a:gradFill>
+        <a:gradFill rotWithShape="1">
+          <a:gsLst>
+            <a:gs pos="0">
+              <a:schemeClr val="phClr">
+                <a:tint val="80000"/>
+                <a:satMod val="300000"/>
+              </a:schemeClr>
+            </a:gs>
+            <a:gs pos="100000">
+              <a:schemeClr val="phClr">
+                <a:shade val="30000"/>
+                <a:satMod val="200000"/>
+              </a:schemeClr>
+            </a:gs>
+          </a:gsLst>
+          <a:path path="circle">
+            <a:fillToRect l="50000" t="50000" r="50000" b="50000"/>
+          </a:path>
+        </a:gradFill>
+      </a:bgFillStyleLst>
+    </a:fmtScheme>
+  </a:themeElements>
+  <a:objectDefaults>
+    <a:spDef>
+      <a:spPr/>
+      <a:bodyPr/>
+      <a:lstStyle/>
+      <a:style>
+        <a:lnRef idx="1">
+          <a:schemeClr val="accent1"/>
+        </a:lnRef>
+        <a:fillRef idx="3">
+          <a:schemeClr val="accent1"/>
+        </a:fillRef>
+        <a:effectRef idx="2">
+          <a:schemeClr val="accent1"/>
+        </a:effectRef>
+        <a:fontRef idx="minor">
+          <a:schemeClr val="lt1"/>
+        </a:fontRef>
+      </a:style>
+    </a:spDef>
+    <a:lnDef>
+      <a:spPr/>
+      <a:bodyPr/>
+      <a:lstStyle/>
+      <a:style>
+        <a:lnRef idx="2">
+          <a:schemeClr val="accent1"/>
+        </a:lnRef>
+        <a:fillRef idx="0">
+          <a:schemeClr val="accent1"/>
+        </a:fillRef>
+        <a:effectRef idx="1">
+          <a:schemeClr val="accent1"/>
+        </a:effectRef>
+        <a:fontRef idx="minor">
+          <a:schemeClr val="tx1"/>
+        </a:fontRef>
+      </a:style>
+    </a:lnDef>
+  </a:objectDefaults>
+  <a:extraClrSchemeLst/>
+</a:theme>
 </file>
</xml_diff>

<commit_message>
Clarity pass: challenge, review and simplify every slide
Slide-by-slide review of all 79 slides against a beginner five-second
test. The fix pattern from the owner's example (the scaling slide):
ground physically first, teach how to read the picture, then the
insight.

- Every chart now carries a "how to read it" line naming the axes, what
  one visual element means, and what to notice
- Jargon removed from inside figures (axis "weight for Fare" is now
  "the model's dial for Fare (its weight)"; start/best markers added)
- Concrete anchors precede every metaphor (Fare 0-512 vs Age 0-80:
  "Fare shouts and Age whispers"; the 0.617 floor now derives itself:
  61.7% of training passengers died)
- No slide requires remembering another session: borrowed ideas are
  restated inline
- Long bullets split to one idea each; speaker notes refreshed and
  extended

Slide counts, order, facts, numbers and attributions unchanged.

Co-Authored-By: Claude Fable 5 <noreply@anthropic.com>
</commit_message>
<xml_diff>
--- a/presentations/m2-session-1-machine-learning-fundamentals.pptx
+++ b/presentations/m2-session-1-machine-learning-fundamentals.pptx
@@ -591,7 +591,7 @@
           <a:lstStyle/>
           <a:p>
             <a:r>
-              <a:t>Demystify training: score every candidate rule by its average miss - one number, J - and hunt for the rule with the smallest J. The hunt is a walk downhill in fog: feel the slope, step where it drops fastest, repeat. Point at the four panels: bad rule big J, decent rule smaller, best rule smallest. Ask the class: what goes wrong if your downhill steps are huge?</a:t>
+              <a:t>Teach the picture before the idea: each dot is a passenger, the blue line is one candidate rule, and every thin vertical line is one miss. J is just the average miss - one number per rule: bad rule big J, decent rule smaller, best rule smallest. Then panel four: training hunts the smallest J by walking downhill in fog - feel the slope, step where it drops fastest, repeat; each dot is one step. Ask the class: what goes wrong if your downhill steps are huge?</a:t>
             </a:r>
           </a:p>
         </p:txBody>
@@ -661,7 +661,7 @@
           <a:lstStyle/>
           <a:p>
             <a:r>
-              <a:t>This is the module's exam metaphor - use it every session: the test set is the final exam, and you sit it exactly once. Leakage is any way the exam answers sneak into the study notes - even an average computed over all rows counts. Tell the KDD story slowly: the patient ID gave away the hospital, and the hospital gave away the diagnosis. Ask the class: why does a suspiciously good feature deserve suspicion first?</a:t>
+              <a:t>Make the dataset feel small and human: 891 rows, one per passenger, 12 columns. The chart just counts the answer column - each bar is one outcome, longer bar = more people: 549 died, 342 survived. Flag the gaps now (Age 177, Cabin 687) - Session 2 fixes them. Ask the class: is 62/38 unbalanced enough to worry about?</a:t>
             </a:r>
           </a:p>
         </p:txBody>
@@ -731,6 +731,146 @@
           <a:lstStyle/>
           <a:p>
             <a:r>
+              <a:t>Walk the boxes left to right - prepare, train, evaluate, improve - then stop on the long arrow underneath: evaluation usually sends you BACK to preparation, not forward. The only exit is up, to ship, when the honest score is good enough. Map each box to a session so the module feels like one walk around this loop. Ask the class: why does the arrow back go to preparation and not to training?</a:t>
+            </a:r>
+          </a:p>
+        </p:txBody>
+      </p:sp>
+      <p:sp>
+        <p:nvSpPr>
+          <p:cNvPr id="4" name="Slide Number Placeholder 3"/>
+          <p:cNvSpPr>
+            <a:spLocks noGrp="1"/>
+          </p:cNvSpPr>
+          <p:nvPr>
+            <p:ph type="sldNum" idx="5" sz="quarter"/>
+          </p:nvPr>
+        </p:nvSpPr>
+        <p:spPr/>
+      </p:sp>
+    </p:spTree>
+  </p:cSld>
+  <p:clrMapOvr>
+    <a:masterClrMapping/>
+  </p:clrMapOvr>
+</p:notes>
+</file>
+
+<file path=ppt/notesSlides/notesSlide13.xml><?xml version="1.0" encoding="utf-8"?>
+<p:notes xmlns:a="http://schemas.openxmlformats.org/drawingml/2006/main" xmlns:p="http://schemas.openxmlformats.org/presentationml/2006/main" xmlns:r="http://schemas.openxmlformats.org/officeDocument/2006/relationships">
+  <p:cSld>
+    <p:spTree>
+      <p:nvGrpSpPr>
+        <p:cNvPr id="1" name=""/>
+        <p:cNvGrpSpPr/>
+        <p:nvPr/>
+      </p:nvGrpSpPr>
+      <p:grpSpPr>
+        <a:xfrm>
+          <a:off x="0" y="0"/>
+          <a:ext cx="0" cy="0"/>
+          <a:chOff x="0" y="0"/>
+          <a:chExt cx="0" cy="0"/>
+        </a:xfrm>
+      </p:grpSpPr>
+      <p:sp>
+        <p:nvSpPr>
+          <p:cNvPr id="2" name="Slide Image Placeholder 1"/>
+          <p:cNvSpPr>
+            <a:spLocks noGrp="1"/>
+          </p:cNvSpPr>
+          <p:nvPr>
+            <p:ph type="sldImg" idx="2"/>
+          </p:nvPr>
+        </p:nvSpPr>
+        <p:spPr/>
+      </p:sp>
+      <p:sp>
+        <p:nvSpPr>
+          <p:cNvPr id="3" name="Notes Placeholder 2"/>
+          <p:cNvSpPr>
+            <a:spLocks noGrp="1"/>
+          </p:cNvSpPr>
+          <p:nvPr>
+            <p:ph type="body" idx="3" sz="quarter"/>
+          </p:nvPr>
+        </p:nvSpPr>
+        <p:spPr/>
+        <p:txBody>
+          <a:bodyPr/>
+          <a:lstStyle/>
+          <a:p>
+            <a:r>
+              <a:t>This is the module's exam metaphor - use it every session: the test set is the final exam, and you sit it exactly once. Leakage is any way the exam answers sneak into the study notes - even an average computed over all rows counts. Tell the KDD story slowly: the patient ID gave away the hospital, and the hospital gave away the diagnosis. Ask the class: why does a suspiciously good feature deserve suspicion first?</a:t>
+            </a:r>
+          </a:p>
+        </p:txBody>
+      </p:sp>
+      <p:sp>
+        <p:nvSpPr>
+          <p:cNvPr id="4" name="Slide Number Placeholder 3"/>
+          <p:cNvSpPr>
+            <a:spLocks noGrp="1"/>
+          </p:cNvSpPr>
+          <p:nvPr>
+            <p:ph type="sldNum" idx="5" sz="quarter"/>
+          </p:nvPr>
+        </p:nvSpPr>
+        <p:spPr/>
+      </p:sp>
+    </p:spTree>
+  </p:cSld>
+  <p:clrMapOvr>
+    <a:masterClrMapping/>
+  </p:clrMapOvr>
+</p:notes>
+</file>
+
+<file path=ppt/notesSlides/notesSlide14.xml><?xml version="1.0" encoding="utf-8"?>
+<p:notes xmlns:a="http://schemas.openxmlformats.org/drawingml/2006/main" xmlns:p="http://schemas.openxmlformats.org/presentationml/2006/main" xmlns:r="http://schemas.openxmlformats.org/officeDocument/2006/relationships">
+  <p:cSld>
+    <p:spTree>
+      <p:nvGrpSpPr>
+        <p:cNvPr id="1" name=""/>
+        <p:cNvGrpSpPr/>
+        <p:nvPr/>
+      </p:nvGrpSpPr>
+      <p:grpSpPr>
+        <a:xfrm>
+          <a:off x="0" y="0"/>
+          <a:ext cx="0" cy="0"/>
+          <a:chOff x="0" y="0"/>
+          <a:chExt cx="0" cy="0"/>
+        </a:xfrm>
+      </p:grpSpPr>
+      <p:sp>
+        <p:nvSpPr>
+          <p:cNvPr id="2" name="Slide Image Placeholder 1"/>
+          <p:cNvSpPr>
+            <a:spLocks noGrp="1"/>
+          </p:cNvSpPr>
+          <p:nvPr>
+            <p:ph type="sldImg" idx="2"/>
+          </p:nvPr>
+        </p:nvSpPr>
+        <p:spPr/>
+      </p:sp>
+      <p:sp>
+        <p:nvSpPr>
+          <p:cNvPr id="3" name="Notes Placeholder 2"/>
+          <p:cNvSpPr>
+            <a:spLocks noGrp="1"/>
+          </p:cNvSpPr>
+          <p:nvPr>
+            <p:ph type="body" idx="3" sz="quarter"/>
+          </p:nvPr>
+        </p:nvSpPr>
+        <p:spPr/>
+        <p:txBody>
+          <a:bodyPr/>
+          <a:lstStyle/>
+          <a:p>
+            <a:r>
               <a:t>A model that ignores everything and always answers 'died' is right 61.7% of the time, simply because most passengers died. That is the floor: any real model must clearly beat it, or it has learned nothing. Ask the class: why is 62% accuracy on this dataset nothing to celebrate?</a:t>
             </a:r>
           </a:p>
@@ -1081,7 +1221,7 @@
           <a:lstStyle/>
           <a:p>
             <a:r>
-              <a:t>Say it as: every outcome is pattern plus luck. The pattern is learnable - class, sex and age really did shape survival. The luck is not: two identical passengers could meet different fates in the chaos. Better features and models shrink the pattern error; nothing shrinks the luck. Ask the class: why would a model claiming 100% accuracy on survival actually be suspicious?</a:t>
+              <a:t>Start concrete: class, sex and age really did shape survival - that is the pattern, and it is learnable. Two identical passengers could still meet different fates in the chaos - that is the luck, and nothing predicts a coin flip. Only then give the symbols: Y = f(X) + epsilon. Walk the bar: full height is all the error; blue shrinks with better features or models, the grey floor never moves. Ask the class: why would a model claiming 100% accuracy on survival be suspicious?</a:t>
             </a:r>
           </a:p>
         </p:txBody>
@@ -4813,7 +4953,7 @@
                 </a:solidFill>
                 <a:latin typeface="Arial"/>
               </a:rPr>
-              <a:t>Hypothesis class - in plain words: you pick the shape of the answer (a line? a curve?)</a:t>
+              <a:t>You pick the shape of the answer first: a line? a curve? - before touching any data</a:t>
             </a:r>
           </a:p>
           <a:p>
@@ -4833,7 +4973,7 @@
                 </a:solidFill>
                 <a:latin typeface="Arial"/>
               </a:rPr>
-              <a:t>One hypothesis = one concrete rule, numbers filled in; the class = all rules of that shape</a:t>
+              <a:t>That menu of shapes is the hypothesis class; one hypothesis = one rule, numbers filled in</a:t>
             </a:r>
           </a:p>
           <a:p>
@@ -4873,7 +5013,7 @@
                 </a:solidFill>
                 <a:latin typeface="Arial"/>
               </a:rPr>
-              <a:t>You pick the family before touching any data - that design call is yours, not the algorithm's</a:t>
+              <a:t>The design call is yours; only the search inside it is the algorithm's</a:t>
             </a:r>
           </a:p>
           <a:p>
@@ -4893,7 +5033,7 @@
                 </a:solidFill>
                 <a:latin typeface="Arial"/>
               </a:rPr>
-              <a:t>A roomier family follows the pattern more closely - and follows the noise too; it cuts both ways</a:t>
+              <a:t>A roomier family (curves) hugs the pattern better - and hugs the noise too</a:t>
             </a:r>
           </a:p>
           <a:p>
@@ -4913,7 +5053,7 @@
                 </a:solidFill>
                 <a:latin typeface="Arial"/>
               </a:rPr>
-              <a:t>MIT splits it: choose the class (Session 3's dial) vs fit the member (training's job)</a:t>
+              <a:t>MIT's split: choosing the class is your job; fitting the member is training's job</a:t>
             </a:r>
           </a:p>
         </p:txBody>
@@ -5330,7 +5470,7 @@
                 </a:solidFill>
                 <a:latin typeface="Arial"/>
               </a:rPr>
-              <a:t>The three-slot recipe - in plain words: a menu of rules + a scorecard + a search</a:t>
+              <a:t>How to read it: top row = the three slots; bottom lane = one worked filling</a:t>
             </a:r>
           </a:p>
           <a:p>
@@ -5827,7 +5967,7 @@
                 </a:solidFill>
                 <a:latin typeface="Arial"/>
               </a:rPr>
-              <a:t>The cost J - in plain words: the average miss over all 891 examples - one number per rule</a:t>
+              <a:t>How to read it: dots = passengers, blue line = a candidate rule, thin verticals = its misses</a:t>
             </a:r>
           </a:p>
           <a:p>
@@ -5847,7 +5987,7 @@
                 </a:solidFill>
                 <a:latin typeface="Arial"/>
               </a:rPr>
-              <a:t>Training = the search for the rule with the smallest J - nothing more mystical than that</a:t>
+              <a:t>The cost J = the average miss over all 891 examples - one number per rule</a:t>
             </a:r>
           </a:p>
           <a:p>
@@ -5867,7 +6007,27 @@
                 </a:solidFill>
                 <a:latin typeface="Arial"/>
               </a:rPr>
-              <a:t>The search walks downhill in fog: nudge the knobs in whichever direction lowers J fastest</a:t>
+              <a:t>Training = the search for the rule with the smallest J</a:t>
+            </a:r>
+          </a:p>
+          <a:p>
+            <a:pPr algn="l" indent="-228600" marL="228600">
+              <a:spcAft>
+                <a:spcPts val="800"/>
+              </a:spcAft>
+              <a:buClr>
+                <a:srgbClr val="1E5EF3"/>
+              </a:buClr>
+              <a:buChar char="—"/>
+            </a:pPr>
+            <a:r>
+              <a:rPr sz="1450" b="0">
+                <a:solidFill>
+                  <a:srgbClr val="202B38"/>
+                </a:solidFill>
+                <a:latin typeface="Arial"/>
+              </a:rPr>
+              <a:t>The search walks downhill in fog: nudge each knob the way that lowers J fastest</a:t>
             </a:r>
           </a:p>
           <a:p>
@@ -6710,7 +6870,7 @@
                 </a:solidFill>
                 <a:latin typeface="Arial"/>
               </a:rPr>
-              <a:t>Class balance in the full dataset. Source: Module 2, notebook 01, section 2.</a:t>
+              <a:t>The Survived column of the full dataset, before any split. Source: Module 2, notebook 01, section 2.</a:t>
             </a:r>
           </a:p>
         </p:txBody>
@@ -9301,7 +9461,7 @@
                 </a:solidFill>
                 <a:latin typeface="Arial"/>
               </a:rPr>
-              <a:t>Prepare: split, clean, encode, scale (Sessions 1-2) - today you started it on the 891-row manifest</a:t>
+              <a:t>Prepare: split, clean, encode, scale (Sessions 1-2) - you start it today</a:t>
             </a:r>
           </a:p>
           <a:p>
@@ -9381,7 +9541,7 @@
                 </a:solidFill>
                 <a:latin typeface="Arial"/>
               </a:rPr>
-              <a:t>Evaluation sends you back to preparation more often than forward</a:t>
+              <a:t>The long arrow back is the point: evaluation sends you to preparation more often than forward</a:t>
             </a:r>
           </a:p>
           <a:p>
@@ -9401,7 +9561,7 @@
                 </a:solidFill>
                 <a:latin typeface="Arial"/>
               </a:rPr>
-              <a:t>Harvard teaches it as a five-stage loop - ask, get, explore, model, communicate: modeling is one box of five, and answers routinely send you back a stage</a:t>
+              <a:t>Harvard's version has five stages - ask, get, explore, model, communicate; modeling is one box of five</a:t>
             </a:r>
           </a:p>
         </p:txBody>
@@ -9838,7 +9998,7 @@
                 </a:solidFill>
                 <a:latin typeface="Arial"/>
               </a:rPr>
-              <a:t>The test set is the final exam - you sit it once; seeing the questions while studying proves nothing</a:t>
+              <a:t>The test set is the final exam - you sit it exactly once</a:t>
             </a:r>
           </a:p>
           <a:p>
@@ -9858,7 +10018,7 @@
                 </a:solidFill>
                 <a:latin typeface="Arial"/>
               </a:rPr>
-              <a:t>Data leakage - in plain words: exam answers sneaking into your study notes</a:t>
+              <a:t>Data leakage = exam answers sneaking into your study notes; the score then proves nothing</a:t>
             </a:r>
           </a:p>
           <a:p>
@@ -10432,7 +10592,7 @@
                 </a:solidFill>
                 <a:latin typeface="Arial"/>
               </a:rPr>
-              <a:t>Dummy classifier, 5-fold cross-validation on the training set. Source: Module 2, notebook 02. Beating the floor is the entry ticket, not the goal. Accuracy is 0-1 loss in disguise - the simplest filling of the recipe's loss slot (MIT 6.390, Intro chapter).</a:t>
+              <a:t>Dummy classifier, scored honestly by 5-fold cross-validation on the training set (Session 3 explains this referee). Source: Module 2, notebook 02. Beating the floor is the entry ticket, not the goal. Accuracy is 0-1 loss in disguise - the recipe's simplest loss slot (MIT 6.390, Intro chapter).</a:t>
             </a:r>
           </a:p>
         </p:txBody>
@@ -10919,7 +11079,7 @@
                 </a:solidFill>
                 <a:latin typeface="Arial"/>
               </a:rPr>
-              <a:t>Part 1, the ideas: ML learns rules from labeled examples - a leap from seen cases to unseen ones, allowed by one assumption (new data looks like old)</a:t>
+              <a:t>Part 1, the ideas: ML learns rules from labeled examples, then leaps to unseen cases</a:t>
             </a:r>
           </a:p>
           <a:p>
@@ -10939,7 +11099,7 @@
                 </a:solidFill>
                 <a:latin typeface="Arial"/>
               </a:rPr>
-              <a:t>You choose the hypothesis class; every learner = model + loss + optimizer, and training = making one number (the cost J) small</a:t>
+              <a:t>One assumption allows the leap: new data looks like old</a:t>
             </a:r>
           </a:p>
           <a:p>
@@ -10959,7 +11119,7 @@
                 </a:solidFill>
                 <a:latin typeface="Arial"/>
               </a:rPr>
-              <a:t>Y = f(X) + ε: we estimate the hidden rule, we never beat the noise</a:t>
+              <a:t>You choose the hypothesis class; every learner = model + loss + optimizer</a:t>
             </a:r>
           </a:p>
           <a:p>
@@ -10979,7 +11139,7 @@
                 </a:solidFill>
                 <a:latin typeface="Arial"/>
               </a:rPr>
-              <a:t>Part 2, the manifest: 891 passengers, split first - 712 train / 179 test, stratified; the test set is the exam you take once</a:t>
+              <a:t>Training = making one number, the cost J, small; and Y = f(X) + ε - we never beat the noise</a:t>
             </a:r>
           </a:p>
           <a:p>
@@ -10999,7 +11159,7 @@
                 </a:solidFill>
                 <a:latin typeface="Arial"/>
               </a:rPr>
-              <a:t>Every claim gets a number, and the floor is 0.617</a:t>
+              <a:t>Part 2, the manifest: 891 passengers, split first - 712 train / 179 test, stratified</a:t>
             </a:r>
           </a:p>
           <a:p>
@@ -11019,7 +11179,27 @@
                 </a:solidFill>
                 <a:latin typeface="Arial"/>
               </a:rPr>
-              <a:t>Practice now, zero setup: open notebook 01 in Colab (badge click), Runtime &gt; Run all, work sections 1-3 - exercises at the end, solutions included, attempt them first</a:t>
+              <a:t>The test set is the exam you take once; every claim gets a number, and the floor is 0.617</a:t>
+            </a:r>
+          </a:p>
+          <a:p>
+            <a:pPr algn="l" indent="-228600" marL="228600">
+              <a:spcAft>
+                <a:spcPts val="1000"/>
+              </a:spcAft>
+              <a:buClr>
+                <a:srgbClr val="1E5EF3"/>
+              </a:buClr>
+              <a:buChar char="—"/>
+            </a:pPr>
+            <a:r>
+              <a:rPr sz="1600" b="0">
+                <a:solidFill>
+                  <a:srgbClr val="B9D0FA"/>
+                </a:solidFill>
+                <a:latin typeface="Arial"/>
+              </a:rPr>
+              <a:t>Practice now, zero setup: notebook 01 in Colab (badge click), Runtime &gt; Run all, sections 1-3 - try the exercises before the solutions</a:t>
             </a:r>
           </a:p>
         </p:txBody>
@@ -11433,7 +11613,7 @@
                 </a:solidFill>
                 <a:latin typeface="Arial"/>
               </a:rPr>
-              <a:t>Same past data - a different question, and an output a program can use. M1 drew the line itself: describing is not predicting. M2 starts exactly there.</a:t>
+              <a:t>How to read it: each row runs left to right - question, input, output, Titanic example. Top row = M1 (describing). Bottom row = M2 (predicting). M1's own closing line: describing is not predicting.</a:t>
             </a:r>
           </a:p>
         </p:txBody>
@@ -11786,7 +11966,7 @@
                 </a:solidFill>
                 <a:latin typeface="Arial"/>
               </a:rPr>
-              <a:t>Descriptive and diagnostic: M1. You told what happened and dug into why - groupbys, crosstabs, correlations</a:t>
+              <a:t>Rungs 1-2 are M1: what happened, and why - your groupbys and crosstabs</a:t>
             </a:r>
           </a:p>
           <a:p>
@@ -11806,7 +11986,7 @@
                 </a:solidFill>
                 <a:latin typeface="Arial"/>
               </a:rPr>
-              <a:t>Predictive: M2, this module. What will happen to a new, unseen case?</a:t>
+              <a:t>Rung 3 is this module: what will happen to a NEW, unseen case?</a:t>
             </a:r>
           </a:p>
           <a:p>
@@ -11826,7 +12006,7 @@
                 </a:solidFill>
                 <a:latin typeface="Arial"/>
               </a:rPr>
-              <a:t>Prescriptive sits on top: what should we do - decisions built on predictions you can trust</a:t>
+              <a:t>Rung 4, prescriptive: what should we do? It needs a trusted model first</a:t>
             </a:r>
           </a:p>
           <a:p>
@@ -11846,7 +12026,7 @@
                 </a:solidFill>
                 <a:latin typeface="Arial"/>
               </a:rPr>
-              <a:t>Your M1 skills still do most of the daily job: 80% of the work is still cleaning and describing data</a:t>
+              <a:t>M1 skills stay in daily use: 80% of the work is still cleaning and describing</a:t>
             </a:r>
           </a:p>
           <a:p>
@@ -11866,7 +12046,7 @@
                 </a:solidFill>
                 <a:latin typeface="Arial"/>
               </a:rPr>
-              <a:t>The climb, session by session: S1 what ML is and honest splits; S2 features; S3 the model tournament; S4 tune and ship</a:t>
+              <a:t>The climb here: S1 ideas and honest splits; S2 features; S3 the model tournament; S4 tune and ship</a:t>
             </a:r>
           </a:p>
         </p:txBody>
@@ -11930,7 +12110,7 @@
                 </a:solidFill>
                 <a:latin typeface="Arial"/>
               </a:rPr>
-              <a:t>MIT draws the same line by goal, not tools: statistics asks 'does the model explain?' - ML asks 'does the prediction hold up?' (MIT 6.390, Intro chapter). Ng, Harvard CS109A and MIT 6.390 all climb this same ladder.</a:t>
+              <a:t>Statistics asks 'does the model explain?' - ML asks 'does the prediction hold up?' (MIT 6.390, Intro chapter). Ng, Harvard CS109A and MIT 6.390 all climb this same ladder.</a:t>
             </a:r>
           </a:p>
         </p:txBody>
@@ -12303,7 +12483,27 @@
                 </a:solidFill>
                 <a:latin typeface="Arial"/>
               </a:rPr>
-              <a:t>A hand-written spam rule list - block 'winner', block ALL CAPS, block unknown senders - never ends, and spammers adapt faster than you can type</a:t>
+              <a:t>A spam rule list - block 'winner', block ALL CAPS, block unknown senders - never ends</a:t>
+            </a:r>
+          </a:p>
+          <a:p>
+            <a:pPr algn="l" lvl="1" indent="-228600" marL="514350">
+              <a:spcAft>
+                <a:spcPts val="600"/>
+              </a:spcAft>
+              <a:buClr>
+                <a:srgbClr val="1E5EF3"/>
+              </a:buClr>
+              <a:buChar char="·"/>
+            </a:pPr>
+            <a:r>
+              <a:rPr sz="1350" b="0">
+                <a:solidFill>
+                  <a:srgbClr val="5B6774"/>
+                </a:solidFill>
+                <a:latin typeface="Arial"/>
+              </a:rPr>
+              <a:t>Spammers adapt faster than you can type new rules</a:t>
             </a:r>
           </a:p>
           <a:p>
@@ -12323,7 +12523,7 @@
                 </a:solidFill>
                 <a:latin typeface="Arial"/>
               </a:rPr>
-              <a:t>Machine learning: you show labeled examples, the algorithm finds the rules</a:t>
+              <a:t>Machine learning: you show labeled examples - the algorithm finds the rules</a:t>
             </a:r>
           </a:p>
           <a:p>
@@ -12343,7 +12543,27 @@
                 </a:solidFill>
                 <a:latin typeface="Arial"/>
               </a:rPr>
-              <a:t>Arthur Samuel called it the "field of study that gives computers the ability to learn without being explicitly programmed" - his 1950s checkers program beat its own programmer after tens of thousands of self-played games</a:t>
+              <a:t>Arthur Samuel: the "field of study that gives computers the ability to learn without being explicitly programmed"</a:t>
+            </a:r>
+          </a:p>
+          <a:p>
+            <a:pPr algn="l" lvl="1" indent="-228600" marL="514350">
+              <a:spcAft>
+                <a:spcPts val="600"/>
+              </a:spcAft>
+              <a:buClr>
+                <a:srgbClr val="1E5EF3"/>
+              </a:buClr>
+              <a:buChar char="·"/>
+            </a:pPr>
+            <a:r>
+              <a:rPr sz="1350" b="0">
+                <a:solidFill>
+                  <a:srgbClr val="5B6774"/>
+                </a:solidFill>
+                <a:latin typeface="Arial"/>
+              </a:rPr>
+              <a:t>His 1950s checkers program beat its own programmer after tens of thousands of self-played games</a:t>
             </a:r>
           </a:p>
           <a:p>
@@ -12383,7 +12603,7 @@
                 </a:solidFill>
                 <a:latin typeface="Arial"/>
               </a:rPr>
-              <a:t>Recommendations predict what you will want next; map arrival times predict a trip nobody has driven in exactly these conditions</a:t>
+              <a:t>Recommendations predict your next pick; map arrival times predict a trip nobody has driven</a:t>
             </a:r>
           </a:p>
           <a:p>
@@ -12403,7 +12623,7 @@
                 </a:solidFill>
                 <a:latin typeface="Arial"/>
               </a:rPr>
-              <a:t>The same move on our data: 891 passengers with known outcomes go in; a pattern that predicts new passengers comes out</a:t>
+              <a:t>Our data, same move: 891 passengers with known outcomes in - a pattern that predicts new ones out</a:t>
             </a:r>
           </a:p>
           <a:p>
@@ -12423,7 +12643,27 @@
                 </a:solidFill>
                 <a:latin typeface="Arial"/>
               </a:rPr>
-              <a:t>A model is a function with adjustable knobs (parameters); training turns the knobs until predictions match the examples</a:t>
+              <a:t>A model = a function with adjustable knobs (its parameters)</a:t>
+            </a:r>
+          </a:p>
+          <a:p>
+            <a:pPr algn="l" indent="-228600" marL="228600">
+              <a:spcAft>
+                <a:spcPts val="800"/>
+              </a:spcAft>
+              <a:buClr>
+                <a:srgbClr val="1E5EF3"/>
+              </a:buClr>
+              <a:buChar char="—"/>
+            </a:pPr>
+            <a:r>
+              <a:rPr sz="1600" b="0">
+                <a:solidFill>
+                  <a:srgbClr val="202B38"/>
+                </a:solidFill>
+                <a:latin typeface="Arial"/>
+              </a:rPr>
+              <a:t>Training = turning the knobs until predictions match the examples</a:t>
             </a:r>
           </a:p>
         </p:txBody>
@@ -12836,7 +13076,27 @@
                 </a:solidFill>
                 <a:latin typeface="Arial"/>
               </a:rPr>
-              <a:t>A spam filter learns from mail already marked spam or not spam - ours: 891 passengers, each labeled Survived, 1 or 0</a:t>
+              <a:t>A spam filter learns from mail already marked spam or not spam</a:t>
+            </a:r>
+          </a:p>
+          <a:p>
+            <a:pPr algn="l" lvl="1" indent="-228600" marL="514350">
+              <a:spcAft>
+                <a:spcPts val="600"/>
+              </a:spcAft>
+              <a:buClr>
+                <a:srgbClr val="1E5EF3"/>
+              </a:buClr>
+              <a:buChar char="·"/>
+            </a:pPr>
+            <a:r>
+              <a:rPr sz="1350" b="0">
+                <a:solidFill>
+                  <a:srgbClr val="5B6774"/>
+                </a:solidFill>
+                <a:latin typeface="Arial"/>
+              </a:rPr>
+              <a:t>Ours: 891 passengers, each labeled Survived - 1 or 0</a:t>
             </a:r>
           </a:p>
           <a:p>
@@ -13453,7 +13713,7 @@
                 </a:solidFill>
                 <a:latin typeface="Arial"/>
               </a:rPr>
-              <a:t>Age, Sex, Pclass, Fare, SibSp, Parch, Embarked</a:t>
+              <a:t>Age, Sex, Pclass (ticket class), Fare, SibSp (siblings + spouse aboard), Parch (parents + children aboard), Embarked</a:t>
             </a:r>
           </a:p>
           <a:p>
@@ -14073,7 +14333,7 @@
                 </a:solidFill>
                 <a:latin typeface="Arial"/>
               </a:rPr>
-              <a:t>Y = f(X) + ε - in plain words: every outcome is pattern plus luck</a:t>
+              <a:t>On the Titanic: class, sex and age shaped survival - that is the pattern</a:t>
             </a:r>
           </a:p>
           <a:p>
@@ -14093,7 +14353,7 @@
                 </a:solidFill>
                 <a:latin typeface="Arial"/>
               </a:rPr>
-              <a:t>f is the pattern - learnable. ε (epsilon) is the luck - nothing predicts a coin flip</a:t>
+              <a:t>Two identical passengers could still meet different fates - that is the luck</a:t>
             </a:r>
           </a:p>
           <a:p>
@@ -14113,7 +14373,7 @@
                 </a:solidFill>
                 <a:latin typeface="Arial"/>
               </a:rPr>
-              <a:t>On the Titanic: class, sex and age shape survival (the pattern); chaos that night is the luck</a:t>
+              <a:t>In symbols, Y = f(X) + ε: outcome = pattern (f) plus luck (ε, epsilon)</a:t>
             </a:r>
           </a:p>
           <a:p>
@@ -14133,7 +14393,7 @@
                 </a:solidFill>
                 <a:latin typeface="Arial"/>
               </a:rPr>
-              <a:t>A model estimates the pattern; the error you can still shrink is called reducible</a:t>
+              <a:t>How to read the bar: its full height is all the error a model makes</a:t>
             </a:r>
           </a:p>
           <a:p>
@@ -14153,7 +14413,27 @@
                 </a:solidFill>
                 <a:latin typeface="Arial"/>
               </a:rPr>
-              <a:t>The luck is an irreducible floor - why 100% accuracy is never the goal; Session 3 pays this off</a:t>
+              <a:t>The blue part (reducible) shrinks: better features, models or data</a:t>
+            </a:r>
+          </a:p>
+          <a:p>
+            <a:pPr algn="l" indent="-228600" marL="228600">
+              <a:spcAft>
+                <a:spcPts val="800"/>
+              </a:spcAft>
+              <a:buClr>
+                <a:srgbClr val="1E5EF3"/>
+              </a:buClr>
+              <a:buChar char="—"/>
+            </a:pPr>
+            <a:r>
+              <a:rPr sz="1450" b="0">
+                <a:solidFill>
+                  <a:srgbClr val="202B38"/>
+                </a:solidFill>
+                <a:latin typeface="Arial"/>
+              </a:rPr>
+              <a:t>The grey floor (irreducible noise) never shrinks - why 100% accuracy is never the goal</a:t>
             </a:r>
           </a:p>
         </p:txBody>
@@ -14570,7 +14850,7 @@
                 </a:solidFill>
                 <a:latin typeface="Arial"/>
               </a:rPr>
-              <a:t>The induction problem - in plain words: after 10 dog photos you recognize an 11th you never saw</a:t>
+              <a:t>After 10 dog photos you recognize an 11th dog you never saw</a:t>
             </a:r>
           </a:p>
           <a:p>
@@ -14590,7 +14870,7 @@
                 </a:solidFill>
                 <a:latin typeface="Arial"/>
               </a:rPr>
-              <a:t>Every learner makes that leap: a few examples in, answers for cases nobody has seen yet</a:t>
+              <a:t>That leap is called induction - every learner makes it: few examples in, unseen cases answered</a:t>
             </a:r>
           </a:p>
           <a:p>

</xml_diff>